<commit_message>
Revise thesis objectives and adopt KDD in topic presentation
</commit_message>
<xml_diff>
--- a/presentaciones/Presentacion-Tema-Tesis-Autocontenida-20-09-2026.pptx
+++ b/presentaciones/Presentacion-Tema-Tesis-Autocontenida-20-09-2026.pptx
@@ -512,7 +512,7 @@
           </a:p>
           <a:p>
             <a:r>
-              <a:t>Conversión editable del HTML del 20-09-2026.</a:t>
+              <a:t>Revisión de objetivos y KDD del 22-09-2026.</a:t>
             </a:r>
           </a:p>
           <a:p/>
@@ -558,7 +558,7 @@
           </a:p>
           <a:p>
             <a:r>
-              <a:t>Proyecto Fondecyt 1231122 · Toma de Muestra 2 · 20 de septiembre de 2026.</a:t>
+              <a:t>Proyecto Fondecyt 1231122 · Toma de Muestra 2 · Revisión del 22 de septiembre de 2026.</a:t>
             </a:r>
           </a:p>
           <a:p>
@@ -638,7 +638,7 @@
           </a:p>
           <a:p>
             <a:r>
-              <a:t>Conversión editable del HTML del 20-09-2026.</a:t>
+              <a:t>Revisión de objetivos y KDD del 22-09-2026.</a:t>
             </a:r>
           </a:p>
           <a:p/>
@@ -764,7 +764,7 @@
           </a:p>
           <a:p>
             <a:r>
-              <a:t>Conversión editable del HTML del 20-09-2026.</a:t>
+              <a:t>Revisión de objetivos y KDD del 22-09-2026.</a:t>
             </a:r>
           </a:p>
           <a:p/>
@@ -775,12 +775,12 @@
           </a:p>
           <a:p>
             <a:r>
-              <a:t>Evaluar el aporte de la temporalidad y la fusión multimodal</a:t>
-            </a:r>
-          </a:p>
-          <a:p>
-            <a:r>
-              <a:t>Desarrollar y evaluar modelos temporales multimodales para la detección de atención y activación emocional durante la navegación web, comparando su desempeño fuera de muestra con modelos estáticos comparables y contrastando distintas estrategias de fusión multimodal.</a:t>
+              <a:t>Evaluar el aporte predictivo de la temporalidad y la fusión</a:t>
+            </a:r>
+          </a:p>
+          <a:p>
+            <a:r>
+              <a:t>Evaluar el aporte de la información temporal y de la fusión multimodal a la predicción de pseudoetiquetas de atención y activación emocional durante la navegación web, mediante la comparación de modelos temporales y estáticos en participantes no utilizados para su ajuste.</a:t>
             </a:r>
           </a:p>
           <a:p>
@@ -810,7 +810,7 @@
           </a:p>
           <a:p>
             <a:r>
-              <a:t>Formulación operacional del objetivo vigente en «Tesis_MDS»; desarrollo en «Estructura Tesis». Fuera de muestra: participantes separados de los usados para ajustar cada modelo.</a:t>
+              <a:t>Objetivo revisado el 22-09-2026. La comparación mantiene las mismas pseudoetiquetas y particiones; estima capacidad predictiva, sin atribuir validez fisiológica directa.</a:t>
             </a:r>
           </a:p>
         </p:txBody>
@@ -885,93 +885,93 @@
           </a:p>
           <a:p>
             <a:r>
-              <a:t>Conversión editable del HTML del 20-09-2026.</a:t>
+              <a:t>Revisión de objetivos y KDD del 22-09-2026.</a:t>
             </a:r>
           </a:p>
           <a:p/>
           <a:p>
             <a:r>
-              <a:t>Objetivos específicos · síntesis de los siete objetivos</a:t>
-            </a:r>
-          </a:p>
-          <a:p>
-            <a:r>
-              <a:t>Del corpus sincronizado al contraste de la hipótesis</a:t>
-            </a:r>
-          </a:p>
-          <a:p>
-            <a:r>
-              <a:t>Sistematizar el estado del arte</a:t>
-            </a:r>
-          </a:p>
-          <a:p>
-            <a:r>
-              <a:t>Revisar atención, activación, dinámica temporal y fusión de señales en navegación web.</a:t>
-            </a:r>
-          </a:p>
-          <a:p>
-            <a:r>
-              <a:t>Construir el corpus multimodal</a:t>
-            </a:r>
-          </a:p>
-          <a:p>
-            <a:r>
-              <a:t>Sincronizar EEG, GSR, mirada y pupila con criterios explícitos de calidad.</a:t>
-            </a:r>
-          </a:p>
-          <a:p>
-            <a:r>
-              <a:t>Diseñar pseudoetiquetas</a:t>
-            </a:r>
-          </a:p>
-          <a:p>
-            <a:r>
-              <a:t>Separar las señales que construyen cada etiqueta de las que la predicen.</a:t>
-            </a:r>
-          </a:p>
-          <a:p>
-            <a:r>
-              <a:t>Desarrollar y evaluar modelos</a:t>
-            </a:r>
-          </a:p>
-          <a:p>
-            <a:r>
-              <a:t>Comparar LSTM, TCN y Transformer con baselines estáticos por participante.</a:t>
-            </a:r>
-          </a:p>
-          <a:p>
-            <a:r>
-              <a:t>Comparar estrategias de fusión</a:t>
-            </a:r>
-          </a:p>
-          <a:p>
-            <a:r>
-              <a:t>Evaluar fusión temprana, intermedia y tardía; medir aportes mediante ablación.</a:t>
-            </a:r>
-          </a:p>
-          <a:p>
-            <a:r>
-              <a:t>Analizar trayectorias intra-sesión</a:t>
-            </a:r>
-          </a:p>
-          <a:p>
-            <a:r>
-              <a:t>Explorar patrones compatibles con fatiga o habituación.</a:t>
-            </a:r>
-          </a:p>
-          <a:p>
-            <a:r>
-              <a:t>Contrastar la hipótesis</a:t>
-            </a:r>
-          </a:p>
-          <a:p>
-            <a:r>
-              <a:t>Establecer resultados, alcances y limitaciones.</a:t>
-            </a:r>
-          </a:p>
-          <a:p>
-            <a:r>
-              <a:t>Síntesis de «Estructura Tesis», objetivos específicos 1–7. El análisis de fatiga/habituación es complementario y descriptivo.</a:t>
+              <a:t>Objetivos específicos</a:t>
+            </a:r>
+          </a:p>
+          <a:p>
+            <a:r>
+              <a:t>Caracterizar, comparar y contrastar con evidencia</a:t>
+            </a:r>
+          </a:p>
+          <a:p>
+            <a:r>
+              <a:t>Sistematizar la evidencia científica</a:t>
+            </a:r>
+          </a:p>
+          <a:p>
+            <a:r>
+              <a:t>sobre temporalidad y fusión multimodal para fundamentar el diseño experimental.</a:t>
+            </a:r>
+          </a:p>
+          <a:p>
+            <a:r>
+              <a:t>Caracterizar e integrar las señales</a:t>
+            </a:r>
+          </a:p>
+          <a:p>
+            <a:r>
+              <a:t>EEG, GSR, mirada y pupila mediante criterios reproducibles de calidad y sincronización.</a:t>
+            </a:r>
+          </a:p>
+          <a:p>
+            <a:r>
+              <a:t>Operacionalizar las variables objetivo</a:t>
+            </a:r>
+          </a:p>
+          <a:p>
+            <a:r>
+              <a:t>con pseudoetiquetas continuas y categóricas, evaluando su estabilidad y separando señales de etiquetado y predicción.</a:t>
+            </a:r>
+          </a:p>
+          <a:p>
+            <a:r>
+              <a:t>Comparar el desempeño predictivo</a:t>
+            </a:r>
+          </a:p>
+          <a:p>
+            <a:r>
+              <a:t>de modelos temporales y estáticos mediante evaluación por participante y selección interna de hiperparámetros.</a:t>
+            </a:r>
+          </a:p>
+          <a:p>
+            <a:r>
+              <a:t>Cuantificar el aporte de la fusión</a:t>
+            </a:r>
+          </a:p>
+          <a:p>
+            <a:r>
+              <a:t>temprana, intermedia y tardía, de las modalidades y del historial mediante comparaciones controladas y ablación.</a:t>
+            </a:r>
+          </a:p>
+          <a:p>
+            <a:r>
+              <a:t>Caracterizar las trayectorias intra-sesión</a:t>
+            </a:r>
+          </a:p>
+          <a:p>
+            <a:r>
+              <a:t>de los scores para identificar patrones compatibles con fatiga o habituación, con alcance descriptivo.</a:t>
+            </a:r>
+          </a:p>
+          <a:p>
+            <a:r>
+              <a:t>Contrastar la hipótesis de investigación</a:t>
+            </a:r>
+          </a:p>
+          <a:p>
+            <a:r>
+              <a:t>estimando la incertidumbre y la variabilidad entre participantes de las diferencias de desempeño.</a:t>
+            </a:r>
+          </a:p>
+          <a:p>
+            <a:r>
+              <a:t>Formulación revisada en «Estructura Tesis», 22-09-2026. La estabilidad de las pseudoetiquetas no equivale a validación externa de los constructos.</a:t>
             </a:r>
           </a:p>
         </p:txBody>
@@ -1046,58 +1046,68 @@
           </a:p>
           <a:p>
             <a:r>
-              <a:t>Conversión editable del HTML del 20-09-2026.</a:t>
+              <a:t>Revisión de objetivos y KDD del 22-09-2026.</a:t>
             </a:r>
           </a:p>
           <a:p/>
           <a:p>
             <a:r>
-              <a:t>Metodología</a:t>
-            </a:r>
-          </a:p>
-          <a:p>
-            <a:r>
-              <a:t>Un protocolo común para comparar modelos y fusiones</a:t>
-            </a:r>
-          </a:p>
-          <a:p>
-            <a:r>
-              <a:t>Preparar</a:t>
-            </a:r>
-          </a:p>
-          <a:p>
-            <a:r>
-              <a:t>Auditar calidad y sincronizar por tiempo. Extraer ventanas de 2 s con paso de 1 s.</a:t>
-            </a:r>
-          </a:p>
-          <a:p>
-            <a:r>
-              <a:t>Etiquetar</a:t>
-            </a:r>
-          </a:p>
-          <a:p>
-            <a:r>
-              <a:t>Construir Attention Score y Arousal Score; conservar el continuo y tres niveles.</a:t>
-            </a:r>
-          </a:p>
-          <a:p>
-            <a:r>
-              <a:t>Modelar</a:t>
-            </a:r>
-          </a:p>
-          <a:p>
-            <a:r>
-              <a:t>Entrenar baselines y redes temporales. Comparar fusiones con etiquetas fijas.</a:t>
-            </a:r>
-          </a:p>
-          <a:p>
-            <a:r>
-              <a:t>Evaluar</a:t>
-            </a:r>
-          </a:p>
-          <a:p>
-            <a:r>
-              <a:t>Separar participantes; ajustar hiperparámetros dentro de entrenamiento y analizar ablaciones.</a:t>
+              <a:t>Metodología · Knowledge Discovery in Databases</a:t>
+            </a:r>
+          </a:p>
+          <a:p>
+            <a:r>
+              <a:t>KDD como marco del análisis multimodal</a:t>
+            </a:r>
+          </a:p>
+          <a:p>
+            <a:r>
+              <a:t>Selección</a:t>
+            </a:r>
+          </a:p>
+          <a:p>
+            <a:r>
+              <a:t>Delimitar participantes, sesiones y señales de la Toma de Muestra 2.</a:t>
+            </a:r>
+          </a:p>
+          <a:p>
+            <a:r>
+              <a:t>Preprocesamiento</a:t>
+            </a:r>
+          </a:p>
+          <a:p>
+            <a:r>
+              <a:t>Auditar calidad, tratar faltantes y sincronizar registros.</a:t>
+            </a:r>
+          </a:p>
+          <a:p>
+            <a:r>
+              <a:t>Transformación</a:t>
+            </a:r>
+          </a:p>
+          <a:p>
+            <a:r>
+              <a:t>Extraer características y pseudoetiquetas en ventanas; construir secuencias.</a:t>
+            </a:r>
+          </a:p>
+          <a:p>
+            <a:r>
+              <a:t>Minería de datos</a:t>
+            </a:r>
+          </a:p>
+          <a:p>
+            <a:r>
+              <a:t>Ajustar modelos estáticos y temporales, fusiones e hiperparámetros dentro de entrenamiento.</a:t>
+            </a:r>
+          </a:p>
+          <a:p>
+            <a:r>
+              <a:t>Interpretación y evaluación</a:t>
+            </a:r>
+          </a:p>
+          <a:p>
+            <a:r>
+              <a:t>Comparar por participante, cuantificar incertidumbre y ablaciones; documentar hallazgos.</a:t>
             </a:r>
           </a:p>
           <a:p>
@@ -1152,12 +1162,17 @@
           </a:p>
           <a:p>
             <a:r>
-              <a:t>Evaluación offline: BA macro por participante, macro-F1 y recall por clase; regresión para los scores continuos. Las pseudoetiquetas no constituyen una medición directa del estado interno.</a:t>
-            </a:r>
-          </a:p>
-          <a:p>
-            <a:r>
-              <a:t>Base: «Resumen Diseño Etiquetas y Modelos», «PREPROCESAMIENTO_MULTIMODAL» y «ETIQUETAS_Y_BASELINES». La normalización original por sesión limita la interpretación en tiempo real.</a:t>
+              <a:t>Proceso iterativo:</a:t>
+            </a:r>
+          </a:p>
+          <a:p>
+            <a:r>
+              <a:t>los resultados retroalimentan las etapas anteriores dentro del desarrollo. Evaluación offline con BA por participante, macro-F1 y recall; sin reutilizar la evaluación final para seleccionar modelos.</a:t>
+            </a:r>
+          </a:p>
+          <a:p>
+            <a:r>
+              <a:t>Adaptación en cinco bloques de KDD: Fayyad, Piatetsky-Shapiro y Smyth (1996), AI Magazine 17(3), 37–54. DOI: 10.1609/aimag.v17i3.1230. La normalización original por sesión limita la interpretación en tiempo real.</a:t>
             </a:r>
           </a:p>
         </p:txBody>
@@ -1232,7 +1247,7 @@
           </a:p>
           <a:p>
             <a:r>
-              <a:t>Conversión editable del HTML del 20-09-2026.</a:t>
+              <a:t>Revisión de objetivos y KDD del 22-09-2026.</a:t>
             </a:r>
           </a:p>
           <a:p/>
@@ -4516,7 +4531,7 @@
               </a:defRPr>
             </a:pPr>
             <a:r>
-              <a:t>Proyecto Fondecyt 1231122 · Toma de Muestra 2 · 20 de septiembre de 2026. Alcance operacional de activación emocional: arousal, sin inferir valencia ni emociones discretas.</a:t>
+              <a:t>Proyecto Fondecyt 1231122 · Toma de Muestra 2 · Revisión del 22 de septiembre de 2026. Alcance operacional de activación emocional: arousal, sin inferir valencia ni emociones discretas.</a:t>
             </a:r>
           </a:p>
         </p:txBody>
@@ -6041,7 +6056,7 @@
               </a:defRPr>
             </a:pPr>
             <a:r>
-              <a:t>Evaluar el aporte de la temporalidad y la fusión multimodal</a:t>
+              <a:t>Evaluar el aporte predictivo de la temporalidad y la fusión</a:t>
             </a:r>
           </a:p>
         </p:txBody>
@@ -6086,7 +6101,7 @@
               </a:defRPr>
             </a:pPr>
             <a:r>
-              <a:t>Formulación operacional del objetivo vigente en «Tesis_MDS»; desarrollo en «Estructura Tesis». Fuera de muestra: participantes separados de los usados para ajustar cada modelo.</a:t>
+              <a:t>Objetivo revisado el 22-09-2026. La comparación mantiene las mismas pseudoetiquetas y particiones; estima capacidad predictiva, sin atribuir validez fisiológica directa.</a:t>
             </a:r>
           </a:p>
         </p:txBody>
@@ -6220,7 +6235,7 @@
               </a:defRPr>
             </a:pPr>
             <a:r>
-              <a:t>Desarrollar y evaluar modelos temporales multimodales para la detección de atención y activación emocional durante la navegación web, comparando su desempeño fuera de muestra con modelos estáticos comparables y contrastando distintas estrategias de fusión multimodal.</a:t>
+              <a:t>Evaluar el aporte de la información temporal y de la fusión multimodal a la predicción de pseudoetiquetas de atención y activación emocional durante la navegación web, mediante la comparación de modelos temporales y estáticos en participantes no utilizados para su ajuste.</a:t>
             </a:r>
           </a:p>
         </p:txBody>
@@ -6736,7 +6751,7 @@
               </a:defRPr>
             </a:pPr>
             <a:r>
-              <a:t>OBJETIVOS ESPECÍFICOS · SÍNTESIS DE LOS SIETE OBJETIVOS</a:t>
+              <a:t>OBJETIVOS ESPECÍFICOS</a:t>
             </a:r>
           </a:p>
         </p:txBody>
@@ -6781,7 +6796,7 @@
               </a:defRPr>
             </a:pPr>
             <a:r>
-              <a:t>Del corpus sincronizado al contraste de la hipótesis</a:t>
+              <a:t>Caracterizar, comparar y contrastar con evidencia</a:t>
             </a:r>
           </a:p>
         </p:txBody>
@@ -6826,7 +6841,7 @@
               </a:defRPr>
             </a:pPr>
             <a:r>
-              <a:t>Síntesis de «Estructura Tesis», objetivos específicos 1–7. El análisis de fatiga/habituación es complementario y descriptivo.</a:t>
+              <a:t>Formulación revisada en «Estructura Tesis», 22-09-2026. La estabilidad de las pseudoetiquetas no equivale a validación externa de los constructos.</a:t>
             </a:r>
           </a:p>
         </p:txBody>
@@ -6961,7 +6976,7 @@
               </a:defRPr>
             </a:pPr>
             <a:r>
-              <a:t>Sistematizar el estado del arte</a:t>
+              <a:t>Sistematizar la evidencia científica</a:t>
             </a:r>
           </a:p>
         </p:txBody>
@@ -6975,7 +6990,7 @@
         <p:spPr>
           <a:xfrm>
             <a:off x="1028700" y="2298700"/>
-            <a:ext cx="4673600" cy="825500"/>
+            <a:ext cx="4673600" cy="889000"/>
           </a:xfrm>
           <a:prstGeom prst="rect">
             <a:avLst/>
@@ -6998,7 +7013,7 @@
               <a:spcAft>
                 <a:spcPts val="0"/>
               </a:spcAft>
-              <a:defRPr sz="1540" b="0">
+              <a:defRPr sz="1450" b="0">
                 <a:solidFill>
                   <a:srgbClr val="12243B"/>
                 </a:solidFill>
@@ -7006,7 +7021,7 @@
               </a:defRPr>
             </a:pPr>
             <a:r>
-              <a:t>Revisar atención, activación, dinámica temporal y fusión de señales en navegación web.</a:t>
+              <a:t>sobre temporalidad y fusión multimodal para fundamentar el diseño experimental.</a:t>
             </a:r>
           </a:p>
         </p:txBody>
@@ -7096,7 +7111,7 @@
               </a:defRPr>
             </a:pPr>
             <a:r>
-              <a:t>Construir el corpus multimodal</a:t>
+              <a:t>Caracterizar e integrar las señales</a:t>
             </a:r>
           </a:p>
         </p:txBody>
@@ -7110,7 +7125,7 @@
         <p:spPr>
           <a:xfrm>
             <a:off x="1028700" y="3606800"/>
-            <a:ext cx="4673600" cy="825500"/>
+            <a:ext cx="4673600" cy="889000"/>
           </a:xfrm>
           <a:prstGeom prst="rect">
             <a:avLst/>
@@ -7133,7 +7148,7 @@
               <a:spcAft>
                 <a:spcPts val="0"/>
               </a:spcAft>
-              <a:defRPr sz="1540" b="0">
+              <a:defRPr sz="1450" b="0">
                 <a:solidFill>
                   <a:srgbClr val="12243B"/>
                 </a:solidFill>
@@ -7141,7 +7156,7 @@
               </a:defRPr>
             </a:pPr>
             <a:r>
-              <a:t>Sincronizar EEG, GSR, mirada y pupila con criterios explícitos de calidad.</a:t>
+              <a:t>EEG, GSR, mirada y pupila mediante criterios reproducibles de calidad y sincronización.</a:t>
             </a:r>
           </a:p>
         </p:txBody>
@@ -7231,7 +7246,7 @@
               </a:defRPr>
             </a:pPr>
             <a:r>
-              <a:t>Diseñar pseudoetiquetas</a:t>
+              <a:t>Operacionalizar las variables objetivo</a:t>
             </a:r>
           </a:p>
         </p:txBody>
@@ -7245,7 +7260,7 @@
         <p:spPr>
           <a:xfrm>
             <a:off x="1028700" y="4914900"/>
-            <a:ext cx="4673600" cy="825500"/>
+            <a:ext cx="4673600" cy="889000"/>
           </a:xfrm>
           <a:prstGeom prst="rect">
             <a:avLst/>
@@ -7268,7 +7283,7 @@
               <a:spcAft>
                 <a:spcPts val="0"/>
               </a:spcAft>
-              <a:defRPr sz="1540" b="0">
+              <a:defRPr sz="1450" b="0">
                 <a:solidFill>
                   <a:srgbClr val="12243B"/>
                 </a:solidFill>
@@ -7276,7 +7291,7 @@
               </a:defRPr>
             </a:pPr>
             <a:r>
-              <a:t>Separar las señales que construyen cada etiqueta de las que la predicen.</a:t>
+              <a:t>con pseudoetiquetas continuas y categóricas, evaluando su estabilidad y separando señales de etiquetado y predicción.</a:t>
             </a:r>
           </a:p>
         </p:txBody>
@@ -7366,7 +7381,7 @@
               </a:defRPr>
             </a:pPr>
             <a:r>
-              <a:t>Desarrollar y evaluar modelos</a:t>
+              <a:t>Comparar el desempeño predictivo</a:t>
             </a:r>
           </a:p>
         </p:txBody>
@@ -7380,7 +7395,7 @@
         <p:spPr>
           <a:xfrm>
             <a:off x="6743700" y="2298700"/>
-            <a:ext cx="4673600" cy="609600"/>
+            <a:ext cx="4673600" cy="774700"/>
           </a:xfrm>
           <a:prstGeom prst="rect">
             <a:avLst/>
@@ -7403,7 +7418,7 @@
               <a:spcAft>
                 <a:spcPts val="0"/>
               </a:spcAft>
-              <a:defRPr sz="1540" b="0">
+              <a:defRPr sz="1450" b="0">
                 <a:solidFill>
                   <a:srgbClr val="12243B"/>
                 </a:solidFill>
@@ -7411,7 +7426,7 @@
               </a:defRPr>
             </a:pPr>
             <a:r>
-              <a:t>Comparar LSTM, TCN y Transformer con baselines estáticos por participante.</a:t>
+              <a:t>de modelos temporales y estáticos mediante evaluación por participante y selección interna de hiperparámetros.</a:t>
             </a:r>
           </a:p>
         </p:txBody>
@@ -7424,7 +7439,7 @@
         </p:nvSpPr>
         <p:spPr>
           <a:xfrm>
-            <a:off x="6350000" y="2971800"/>
+            <a:off x="6350000" y="2997200"/>
             <a:ext cx="317500" cy="317500"/>
           </a:xfrm>
           <a:prstGeom prst="rect">
@@ -7469,7 +7484,7 @@
         </p:nvSpPr>
         <p:spPr>
           <a:xfrm>
-            <a:off x="6743700" y="2971800"/>
+            <a:off x="6743700" y="2997200"/>
             <a:ext cx="4673600" cy="330200"/>
           </a:xfrm>
           <a:prstGeom prst="rect">
@@ -7501,7 +7516,7 @@
               </a:defRPr>
             </a:pPr>
             <a:r>
-              <a:t>Comparar estrategias de fusión</a:t>
+              <a:t>Cuantificar el aporte de la fusión</a:t>
             </a:r>
           </a:p>
         </p:txBody>
@@ -7514,8 +7529,8 @@
         </p:nvSpPr>
         <p:spPr>
           <a:xfrm>
-            <a:off x="6743700" y="3327400"/>
-            <a:ext cx="4673600" cy="609600"/>
+            <a:off x="6743700" y="3352800"/>
+            <a:ext cx="4673600" cy="774700"/>
           </a:xfrm>
           <a:prstGeom prst="rect">
             <a:avLst/>
@@ -7538,7 +7553,7 @@
               <a:spcAft>
                 <a:spcPts val="0"/>
               </a:spcAft>
-              <a:defRPr sz="1540" b="0">
+              <a:defRPr sz="1450" b="0">
                 <a:solidFill>
                   <a:srgbClr val="12243B"/>
                 </a:solidFill>
@@ -7546,7 +7561,7 @@
               </a:defRPr>
             </a:pPr>
             <a:r>
-              <a:t>Evaluar fusión temprana, intermedia y tardía; medir aportes mediante ablación.</a:t>
+              <a:t>temprana, intermedia y tardía, de las modalidades y del historial mediante comparaciones controladas y ablación.</a:t>
             </a:r>
           </a:p>
         </p:txBody>
@@ -7559,7 +7574,7 @@
         </p:nvSpPr>
         <p:spPr>
           <a:xfrm>
-            <a:off x="6350000" y="4000500"/>
+            <a:off x="6350000" y="4152900"/>
             <a:ext cx="317500" cy="317500"/>
           </a:xfrm>
           <a:prstGeom prst="rect">
@@ -7604,7 +7619,7 @@
         </p:nvSpPr>
         <p:spPr>
           <a:xfrm>
-            <a:off x="6743700" y="4000500"/>
+            <a:off x="6743700" y="4152900"/>
             <a:ext cx="4673600" cy="330200"/>
           </a:xfrm>
           <a:prstGeom prst="rect">
@@ -7636,7 +7651,7 @@
               </a:defRPr>
             </a:pPr>
             <a:r>
-              <a:t>Analizar trayectorias intra-sesión</a:t>
+              <a:t>Caracterizar las trayectorias intra-sesión</a:t>
             </a:r>
           </a:p>
         </p:txBody>
@@ -7649,8 +7664,8 @@
         </p:nvSpPr>
         <p:spPr>
           <a:xfrm>
-            <a:off x="6743700" y="4356100"/>
-            <a:ext cx="4673600" cy="609600"/>
+            <a:off x="6743700" y="4508500"/>
+            <a:ext cx="4673600" cy="774700"/>
           </a:xfrm>
           <a:prstGeom prst="rect">
             <a:avLst/>
@@ -7673,7 +7688,7 @@
               <a:spcAft>
                 <a:spcPts val="0"/>
               </a:spcAft>
-              <a:defRPr sz="1540" b="0">
+              <a:defRPr sz="1450" b="0">
                 <a:solidFill>
                   <a:srgbClr val="12243B"/>
                 </a:solidFill>
@@ -7681,7 +7696,7 @@
               </a:defRPr>
             </a:pPr>
             <a:r>
-              <a:t>Explorar patrones compatibles con fatiga o habituación.</a:t>
+              <a:t>de los scores para identificar patrones compatibles con fatiga o habituación, con alcance descriptivo.</a:t>
             </a:r>
           </a:p>
         </p:txBody>
@@ -7694,7 +7709,7 @@
         </p:nvSpPr>
         <p:spPr>
           <a:xfrm>
-            <a:off x="6350000" y="5029200"/>
+            <a:off x="6350000" y="5207000"/>
             <a:ext cx="317500" cy="317500"/>
           </a:xfrm>
           <a:prstGeom prst="rect">
@@ -7739,7 +7754,7 @@
         </p:nvSpPr>
         <p:spPr>
           <a:xfrm>
-            <a:off x="6743700" y="5029200"/>
+            <a:off x="6743700" y="5207000"/>
             <a:ext cx="4673600" cy="330200"/>
           </a:xfrm>
           <a:prstGeom prst="rect">
@@ -7771,7 +7786,7 @@
               </a:defRPr>
             </a:pPr>
             <a:r>
-              <a:t>Contrastar la hipótesis</a:t>
+              <a:t>Contrastar la hipótesis de investigación</a:t>
             </a:r>
           </a:p>
         </p:txBody>
@@ -7784,8 +7799,8 @@
         </p:nvSpPr>
         <p:spPr>
           <a:xfrm>
-            <a:off x="6743700" y="5384800"/>
-            <a:ext cx="4673600" cy="609600"/>
+            <a:off x="6743700" y="5562600"/>
+            <a:ext cx="4673600" cy="774700"/>
           </a:xfrm>
           <a:prstGeom prst="rect">
             <a:avLst/>
@@ -7808,7 +7823,7 @@
               <a:spcAft>
                 <a:spcPts val="0"/>
               </a:spcAft>
-              <a:defRPr sz="1540" b="0">
+              <a:defRPr sz="1450" b="0">
                 <a:solidFill>
                   <a:srgbClr val="12243B"/>
                 </a:solidFill>
@@ -7816,7 +7831,7 @@
               </a:defRPr>
             </a:pPr>
             <a:r>
-              <a:t>Establecer resultados, alcances y limitaciones.</a:t>
+              <a:t>estimando la incertidumbre y la variabilidad entre participantes de las diferencias de desempeño.</a:t>
             </a:r>
           </a:p>
         </p:txBody>
@@ -7931,7 +7946,7 @@
               </a:defRPr>
             </a:pPr>
             <a:r>
-              <a:t>METODOLOGÍA</a:t>
+              <a:t>METODOLOGÍA · KNOWLEDGE DISCOVERY IN DATABASES</a:t>
             </a:r>
           </a:p>
         </p:txBody>
@@ -7976,7 +7991,7 @@
               </a:defRPr>
             </a:pPr>
             <a:r>
-              <a:t>Un protocolo común para comparar modelos y fusiones</a:t>
+              <a:t>KDD como marco del análisis multimodal</a:t>
             </a:r>
           </a:p>
         </p:txBody>
@@ -8021,7 +8036,7 @@
               </a:defRPr>
             </a:pPr>
             <a:r>
-              <a:t>Base: «Resumen Diseño Etiquetas y Modelos», «PREPROCESAMIENTO_MULTIMODAL» y «ETIQUETAS_Y_BASELINES». La normalización original por sesión limita la interpretación en tiempo real.</a:t>
+              <a:t>Adaptación en cinco bloques de KDD: Fayyad, Piatetsky-Shapiro y Smyth (1996), AI Magazine 17(3), 37–54. DOI: 10.1609/aimag.v17i3.1230. La normalización original por sesión limita la interpretación en tiempo real.</a:t>
             </a:r>
           </a:p>
         </p:txBody>
@@ -8079,8 +8094,8 @@
         </p:nvSpPr>
         <p:spPr>
           <a:xfrm>
-            <a:off x="635000" y="1905000"/>
-            <a:ext cx="2578100" cy="1676400"/>
+            <a:off x="635000" y="1879600"/>
+            <a:ext cx="2032000" cy="2019300"/>
           </a:xfrm>
           <a:prstGeom prst="rect">
             <a:avLst/>
@@ -8123,7 +8138,7 @@
         </p:nvSpPr>
         <p:spPr>
           <a:xfrm>
-            <a:off x="787400" y="2019300"/>
+            <a:off x="787400" y="2006600"/>
             <a:ext cx="508000" cy="279400"/>
           </a:xfrm>
           <a:prstGeom prst="rect">
@@ -8147,7 +8162,7 @@
               <a:spcAft>
                 <a:spcPts val="0"/>
               </a:spcAft>
-              <a:defRPr sz="1800" b="1">
+              <a:defRPr sz="1700" b="1">
                 <a:solidFill>
                   <a:srgbClr val="09686B"/>
                 </a:solidFill>
@@ -8169,7 +8184,7 @@
         <p:spPr>
           <a:xfrm>
             <a:off x="787400" y="2362200"/>
-            <a:ext cx="2273300" cy="279400"/>
+            <a:ext cx="1727200" cy="444500"/>
           </a:xfrm>
           <a:prstGeom prst="rect">
             <a:avLst/>
@@ -8192,7 +8207,7 @@
               <a:spcAft>
                 <a:spcPts val="0"/>
               </a:spcAft>
-              <a:defRPr sz="1500" b="1">
+              <a:defRPr sz="1370" b="1">
                 <a:solidFill>
                   <a:srgbClr val="12243B"/>
                 </a:solidFill>
@@ -8200,7 +8215,7 @@
               </a:defRPr>
             </a:pPr>
             <a:r>
-              <a:t>Preparar</a:t>
+              <a:t>Selección</a:t>
             </a:r>
           </a:p>
         </p:txBody>
@@ -8213,8 +8228,8 @@
         </p:nvSpPr>
         <p:spPr>
           <a:xfrm>
-            <a:off x="762000" y="2705100"/>
-            <a:ext cx="2324100" cy="812800"/>
+            <a:off x="749300" y="2946400"/>
+            <a:ext cx="1803400" cy="863600"/>
           </a:xfrm>
           <a:prstGeom prst="rect">
             <a:avLst/>
@@ -8237,7 +8252,7 @@
               <a:spcAft>
                 <a:spcPts val="0"/>
               </a:spcAft>
-              <a:defRPr sz="1250" b="0">
+              <a:defRPr sz="1140" b="0">
                 <a:solidFill>
                   <a:srgbClr val="12243B"/>
                 </a:solidFill>
@@ -8245,7 +8260,7 @@
               </a:defRPr>
             </a:pPr>
             <a:r>
-              <a:t>Auditar calidad y sincronizar por tiempo. Extraer ventanas de 2 s con paso de 1 s.</a:t>
+              <a:t>Delimitar participantes, sesiones y señales de la Toma de Muestra 2.</a:t>
             </a:r>
           </a:p>
         </p:txBody>
@@ -8258,8 +8273,8 @@
         </p:nvSpPr>
         <p:spPr>
           <a:xfrm>
-            <a:off x="3416300" y="1905000"/>
-            <a:ext cx="2578100" cy="1676400"/>
+            <a:off x="2857500" y="1879600"/>
+            <a:ext cx="2032000" cy="2019300"/>
           </a:xfrm>
           <a:prstGeom prst="rect">
             <a:avLst/>
@@ -8302,7 +8317,7 @@
         </p:nvSpPr>
         <p:spPr>
           <a:xfrm>
-            <a:off x="3568700" y="2019300"/>
+            <a:off x="3009900" y="2006600"/>
             <a:ext cx="508000" cy="279400"/>
           </a:xfrm>
           <a:prstGeom prst="rect">
@@ -8326,7 +8341,7 @@
               <a:spcAft>
                 <a:spcPts val="0"/>
               </a:spcAft>
-              <a:defRPr sz="1800" b="1">
+              <a:defRPr sz="1700" b="1">
                 <a:solidFill>
                   <a:srgbClr val="09686B"/>
                 </a:solidFill>
@@ -8347,8 +8362,8 @@
         </p:nvSpPr>
         <p:spPr>
           <a:xfrm>
-            <a:off x="3568700" y="2362200"/>
-            <a:ext cx="2273300" cy="279400"/>
+            <a:off x="3009900" y="2362200"/>
+            <a:ext cx="1727200" cy="444500"/>
           </a:xfrm>
           <a:prstGeom prst="rect">
             <a:avLst/>
@@ -8371,7 +8386,7 @@
               <a:spcAft>
                 <a:spcPts val="0"/>
               </a:spcAft>
-              <a:defRPr sz="1500" b="1">
+              <a:defRPr sz="1370" b="1">
                 <a:solidFill>
                   <a:srgbClr val="12243B"/>
                 </a:solidFill>
@@ -8379,7 +8394,7 @@
               </a:defRPr>
             </a:pPr>
             <a:r>
-              <a:t>Etiquetar</a:t>
+              <a:t>Preprocesamiento</a:t>
             </a:r>
           </a:p>
         </p:txBody>
@@ -8392,8 +8407,8 @@
         </p:nvSpPr>
         <p:spPr>
           <a:xfrm>
-            <a:off x="3543300" y="2705100"/>
-            <a:ext cx="2324100" cy="812800"/>
+            <a:off x="2971800" y="2946400"/>
+            <a:ext cx="1803400" cy="863600"/>
           </a:xfrm>
           <a:prstGeom prst="rect">
             <a:avLst/>
@@ -8416,7 +8431,7 @@
               <a:spcAft>
                 <a:spcPts val="0"/>
               </a:spcAft>
-              <a:defRPr sz="1250" b="0">
+              <a:defRPr sz="1140" b="0">
                 <a:solidFill>
                   <a:srgbClr val="12243B"/>
                 </a:solidFill>
@@ -8424,7 +8439,7 @@
               </a:defRPr>
             </a:pPr>
             <a:r>
-              <a:t>Construir Attention Score y Arousal Score; conservar el continuo y tres niveles.</a:t>
+              <a:t>Auditar calidad, tratar faltantes y sincronizar registros.</a:t>
             </a:r>
           </a:p>
         </p:txBody>
@@ -8437,8 +8452,8 @@
         </p:nvSpPr>
         <p:spPr>
           <a:xfrm>
-            <a:off x="6197600" y="1905000"/>
-            <a:ext cx="2578100" cy="1676400"/>
+            <a:off x="5080000" y="1879600"/>
+            <a:ext cx="2032000" cy="2019300"/>
           </a:xfrm>
           <a:prstGeom prst="rect">
             <a:avLst/>
@@ -8481,7 +8496,7 @@
         </p:nvSpPr>
         <p:spPr>
           <a:xfrm>
-            <a:off x="6350000" y="2019300"/>
+            <a:off x="5232400" y="2006600"/>
             <a:ext cx="508000" cy="279400"/>
           </a:xfrm>
           <a:prstGeom prst="rect">
@@ -8505,7 +8520,7 @@
               <a:spcAft>
                 <a:spcPts val="0"/>
               </a:spcAft>
-              <a:defRPr sz="1800" b="1">
+              <a:defRPr sz="1700" b="1">
                 <a:solidFill>
                   <a:srgbClr val="09686B"/>
                 </a:solidFill>
@@ -8526,8 +8541,8 @@
         </p:nvSpPr>
         <p:spPr>
           <a:xfrm>
-            <a:off x="6350000" y="2362200"/>
-            <a:ext cx="2273300" cy="279400"/>
+            <a:off x="5232400" y="2362200"/>
+            <a:ext cx="1727200" cy="444500"/>
           </a:xfrm>
           <a:prstGeom prst="rect">
             <a:avLst/>
@@ -8550,7 +8565,7 @@
               <a:spcAft>
                 <a:spcPts val="0"/>
               </a:spcAft>
-              <a:defRPr sz="1500" b="1">
+              <a:defRPr sz="1370" b="1">
                 <a:solidFill>
                   <a:srgbClr val="12243B"/>
                 </a:solidFill>
@@ -8558,7 +8573,7 @@
               </a:defRPr>
             </a:pPr>
             <a:r>
-              <a:t>Modelar</a:t>
+              <a:t>Transformación</a:t>
             </a:r>
           </a:p>
         </p:txBody>
@@ -8571,8 +8586,8 @@
         </p:nvSpPr>
         <p:spPr>
           <a:xfrm>
-            <a:off x="6324600" y="2705100"/>
-            <a:ext cx="2324100" cy="812800"/>
+            <a:off x="5194300" y="2946400"/>
+            <a:ext cx="1803400" cy="863600"/>
           </a:xfrm>
           <a:prstGeom prst="rect">
             <a:avLst/>
@@ -8595,7 +8610,7 @@
               <a:spcAft>
                 <a:spcPts val="0"/>
               </a:spcAft>
-              <a:defRPr sz="1250" b="0">
+              <a:defRPr sz="1140" b="0">
                 <a:solidFill>
                   <a:srgbClr val="12243B"/>
                 </a:solidFill>
@@ -8603,7 +8618,7 @@
               </a:defRPr>
             </a:pPr>
             <a:r>
-              <a:t>Entrenar baselines y redes temporales. Comparar fusiones con etiquetas fijas.</a:t>
+              <a:t>Extraer características y pseudoetiquetas en ventanas; construir secuencias.</a:t>
             </a:r>
           </a:p>
         </p:txBody>
@@ -8616,8 +8631,8 @@
         </p:nvSpPr>
         <p:spPr>
           <a:xfrm>
-            <a:off x="8978900" y="1905000"/>
-            <a:ext cx="2578100" cy="1676400"/>
+            <a:off x="7302500" y="1879600"/>
+            <a:ext cx="2032000" cy="2019300"/>
           </a:xfrm>
           <a:prstGeom prst="rect">
             <a:avLst/>
@@ -8660,7 +8675,7 @@
         </p:nvSpPr>
         <p:spPr>
           <a:xfrm>
-            <a:off x="9131300" y="2019300"/>
+            <a:off x="7454900" y="2006600"/>
             <a:ext cx="508000" cy="279400"/>
           </a:xfrm>
           <a:prstGeom prst="rect">
@@ -8684,7 +8699,7 @@
               <a:spcAft>
                 <a:spcPts val="0"/>
               </a:spcAft>
-              <a:defRPr sz="1800" b="1">
+              <a:defRPr sz="1700" b="1">
                 <a:solidFill>
                   <a:srgbClr val="09686B"/>
                 </a:solidFill>
@@ -8705,8 +8720,8 @@
         </p:nvSpPr>
         <p:spPr>
           <a:xfrm>
-            <a:off x="9131300" y="2362200"/>
-            <a:ext cx="2273300" cy="279400"/>
+            <a:off x="7454900" y="2362200"/>
+            <a:ext cx="1727200" cy="444500"/>
           </a:xfrm>
           <a:prstGeom prst="rect">
             <a:avLst/>
@@ -8729,7 +8744,7 @@
               <a:spcAft>
                 <a:spcPts val="0"/>
               </a:spcAft>
-              <a:defRPr sz="1500" b="1">
+              <a:defRPr sz="1370" b="1">
                 <a:solidFill>
                   <a:srgbClr val="12243B"/>
                 </a:solidFill>
@@ -8737,7 +8752,7 @@
               </a:defRPr>
             </a:pPr>
             <a:r>
-              <a:t>Evaluar</a:t>
+              <a:t>Minería de datos</a:t>
             </a:r>
           </a:p>
         </p:txBody>
@@ -8750,8 +8765,8 @@
         </p:nvSpPr>
         <p:spPr>
           <a:xfrm>
-            <a:off x="9105900" y="2705100"/>
-            <a:ext cx="2324100" cy="812800"/>
+            <a:off x="7416800" y="2946400"/>
+            <a:ext cx="1803400" cy="863600"/>
           </a:xfrm>
           <a:prstGeom prst="rect">
             <a:avLst/>
@@ -8774,7 +8789,7 @@
               <a:spcAft>
                 <a:spcPts val="0"/>
               </a:spcAft>
-              <a:defRPr sz="1250" b="0">
+              <a:defRPr sz="1140" b="0">
                 <a:solidFill>
                   <a:srgbClr val="12243B"/>
                 </a:solidFill>
@@ -8782,207 +8797,27 @@
               </a:defRPr>
             </a:pPr>
             <a:r>
-              <a:t>Separar participantes; ajustar hiperparámetros dentro de entrenamiento y analizar ablaciones.</a:t>
-            </a:r>
-          </a:p>
-        </p:txBody>
-      </p:sp>
-      <p:sp>
-        <p:nvSpPr>
-          <p:cNvPr id="23" name="TextBox 22"/>
-          <p:cNvSpPr txBox="1"/>
-          <p:nvPr/>
-        </p:nvSpPr>
-        <p:spPr>
-          <a:xfrm>
-            <a:off x="635000" y="3771900"/>
-            <a:ext cx="10922000" cy="279400"/>
-          </a:xfrm>
-          <a:prstGeom prst="rect">
-            <a:avLst/>
-          </a:prstGeom>
-          <a:noFill/>
-        </p:spPr>
-        <p:txBody>
-          <a:bodyPr wrap="square" lIns="0" rIns="0" tIns="0" bIns="0">
-            <a:noAutofit/>
-          </a:bodyPr>
-          <a:lstStyle/>
-          <a:p>
-            <a:pPr>
-              <a:lnSpc>
-                <a:spcPct val="112000"/>
-              </a:lnSpc>
-              <a:spcBef>
-                <a:spcPts val="0"/>
-              </a:spcBef>
-              <a:spcAft>
-                <a:spcPts val="0"/>
-              </a:spcAft>
-              <a:defRPr sz="1150" b="0">
-                <a:solidFill>
-                  <a:srgbClr val="46556B"/>
-                </a:solidFill>
-                <a:latin typeface="Arial"/>
-              </a:defRPr>
-            </a:pPr>
-            <a:r>
-              <a:t>Modelo Profesor → pseudoetiqueta → Modelo Estudiante</a:t>
-            </a:r>
-          </a:p>
-        </p:txBody>
-      </p:sp>
-      <p:sp>
-        <p:nvSpPr>
-          <p:cNvPr id="24" name="TextBox 23"/>
-          <p:cNvSpPr txBox="1"/>
-          <p:nvPr/>
-        </p:nvSpPr>
-        <p:spPr>
-          <a:xfrm>
-            <a:off x="685800" y="4140200"/>
-            <a:ext cx="2159000" cy="368300"/>
-          </a:xfrm>
-          <a:prstGeom prst="rect">
-            <a:avLst/>
-          </a:prstGeom>
-          <a:noFill/>
-        </p:spPr>
-        <p:txBody>
-          <a:bodyPr wrap="square" lIns="0" rIns="0" tIns="0" bIns="0">
-            <a:noAutofit/>
-          </a:bodyPr>
-          <a:lstStyle/>
-          <a:p>
-            <a:pPr>
-              <a:lnSpc>
-                <a:spcPct val="112000"/>
-              </a:lnSpc>
-              <a:spcBef>
-                <a:spcPts val="0"/>
-              </a:spcBef>
-              <a:spcAft>
-                <a:spcPts val="0"/>
-              </a:spcAft>
-              <a:defRPr sz="1100" b="1">
-                <a:solidFill>
-                  <a:srgbClr val="46556B"/>
-                </a:solidFill>
-                <a:latin typeface="Arial"/>
-              </a:defRPr>
-            </a:pPr>
-            <a:r>
-              <a:t>Variable objetivo</a:t>
-            </a:r>
-          </a:p>
-        </p:txBody>
-      </p:sp>
-      <p:sp>
-        <p:nvSpPr>
-          <p:cNvPr id="25" name="TextBox 24"/>
-          <p:cNvSpPr txBox="1"/>
-          <p:nvPr/>
-        </p:nvSpPr>
-        <p:spPr>
-          <a:xfrm>
-            <a:off x="3175000" y="4140200"/>
-            <a:ext cx="3721100" cy="368300"/>
-          </a:xfrm>
-          <a:prstGeom prst="rect">
-            <a:avLst/>
-          </a:prstGeom>
-          <a:noFill/>
-        </p:spPr>
-        <p:txBody>
-          <a:bodyPr wrap="square" lIns="0" rIns="0" tIns="0" bIns="0">
-            <a:noAutofit/>
-          </a:bodyPr>
-          <a:lstStyle/>
-          <a:p>
-            <a:pPr>
-              <a:lnSpc>
-                <a:spcPct val="112000"/>
-              </a:lnSpc>
-              <a:spcBef>
-                <a:spcPts val="0"/>
-              </a:spcBef>
-              <a:spcAft>
-                <a:spcPts val="0"/>
-              </a:spcAft>
-              <a:defRPr sz="1100" b="1">
-                <a:solidFill>
-                  <a:srgbClr val="46556B"/>
-                </a:solidFill>
-                <a:latin typeface="Arial"/>
-              </a:defRPr>
-            </a:pPr>
-            <a:r>
-              <a:t>Profesor: construye la etiqueta</a:t>
-            </a:r>
-          </a:p>
-        </p:txBody>
-      </p:sp>
-      <p:sp>
-        <p:nvSpPr>
-          <p:cNvPr id="26" name="TextBox 25"/>
-          <p:cNvSpPr txBox="1"/>
-          <p:nvPr/>
-        </p:nvSpPr>
-        <p:spPr>
-          <a:xfrm>
-            <a:off x="7213600" y="4140200"/>
-            <a:ext cx="4292600" cy="368300"/>
-          </a:xfrm>
-          <a:prstGeom prst="rect">
-            <a:avLst/>
-          </a:prstGeom>
-          <a:noFill/>
-        </p:spPr>
-        <p:txBody>
-          <a:bodyPr wrap="square" lIns="0" rIns="0" tIns="0" bIns="0">
-            <a:noAutofit/>
-          </a:bodyPr>
-          <a:lstStyle/>
-          <a:p>
-            <a:pPr>
-              <a:lnSpc>
-                <a:spcPct val="112000"/>
-              </a:lnSpc>
-              <a:spcBef>
-                <a:spcPts val="0"/>
-              </a:spcBef>
-              <a:spcAft>
-                <a:spcPts val="0"/>
-              </a:spcAft>
-              <a:defRPr sz="1100" b="1">
-                <a:solidFill>
-                  <a:srgbClr val="46556B"/>
-                </a:solidFill>
-                <a:latin typeface="Arial"/>
-              </a:defRPr>
-            </a:pPr>
-            <a:r>
-              <a:t>Estudiante: predice</a:t>
-            </a:r>
-          </a:p>
-        </p:txBody>
-      </p:sp>
-      <p:sp>
-        <p:nvSpPr>
-          <p:cNvPr id="27" name="Rectangle 26"/>
+              <a:t>Ajustar modelos estáticos y temporales, fusiones e hiperparámetros dentro de entrenamiento.</a:t>
+            </a:r>
+          </a:p>
+        </p:txBody>
+      </p:sp>
+      <p:sp>
+        <p:nvSpPr>
+          <p:cNvPr id="23" name="Rectangle 22"/>
           <p:cNvSpPr/>
           <p:nvPr/>
         </p:nvSpPr>
         <p:spPr>
           <a:xfrm>
-            <a:off x="635000" y="4521200"/>
-            <a:ext cx="10922000" cy="7620"/>
+            <a:off x="9525000" y="1879600"/>
+            <a:ext cx="2032000" cy="2019300"/>
           </a:xfrm>
           <a:prstGeom prst="rect">
             <a:avLst/>
           </a:prstGeom>
           <a:solidFill>
-            <a:srgbClr val="CCD7E2"/>
+            <a:srgbClr val="EFF4F9"/>
           </a:solidFill>
           <a:ln>
             <a:noFill/>
@@ -9013,14 +8848,14 @@
       </p:sp>
       <p:sp>
         <p:nvSpPr>
-          <p:cNvPr id="28" name="TextBox 27"/>
+          <p:cNvPr id="24" name="TextBox 23"/>
           <p:cNvSpPr txBox="1"/>
           <p:nvPr/>
         </p:nvSpPr>
         <p:spPr>
           <a:xfrm>
-            <a:off x="685800" y="4572000"/>
-            <a:ext cx="2159000" cy="368300"/>
+            <a:off x="9677400" y="2006600"/>
+            <a:ext cx="508000" cy="279400"/>
           </a:xfrm>
           <a:prstGeom prst="rect">
             <a:avLst/>
@@ -9043,29 +8878,29 @@
               <a:spcAft>
                 <a:spcPts val="0"/>
               </a:spcAft>
-              <a:defRPr sz="1300" b="1">
-                <a:solidFill>
-                  <a:srgbClr val="12243B"/>
+              <a:defRPr sz="1700" b="1">
+                <a:solidFill>
+                  <a:srgbClr val="09686B"/>
                 </a:solidFill>
                 <a:latin typeface="Arial"/>
               </a:defRPr>
             </a:pPr>
             <a:r>
-              <a:t>Atención</a:t>
-            </a:r>
-          </a:p>
-        </p:txBody>
-      </p:sp>
-      <p:sp>
-        <p:nvSpPr>
-          <p:cNvPr id="29" name="TextBox 28"/>
+              <a:t>05</a:t>
+            </a:r>
+          </a:p>
+        </p:txBody>
+      </p:sp>
+      <p:sp>
+        <p:nvSpPr>
+          <p:cNvPr id="25" name="TextBox 24"/>
           <p:cNvSpPr txBox="1"/>
           <p:nvPr/>
         </p:nvSpPr>
         <p:spPr>
           <a:xfrm>
-            <a:off x="3175000" y="4572000"/>
-            <a:ext cx="3721100" cy="368300"/>
+            <a:off x="9677400" y="2362200"/>
+            <a:ext cx="1727200" cy="444500"/>
           </a:xfrm>
           <a:prstGeom prst="rect">
             <a:avLst/>
@@ -9088,7 +8923,7 @@
               <a:spcAft>
                 <a:spcPts val="0"/>
               </a:spcAft>
-              <a:defRPr sz="1300" b="0">
+              <a:defRPr sz="1370" b="1">
                 <a:solidFill>
                   <a:srgbClr val="12243B"/>
                 </a:solidFill>
@@ -9096,21 +8931,21 @@
               </a:defRPr>
             </a:pPr>
             <a:r>
-              <a:t>Eye tracking + pupilometría</a:t>
-            </a:r>
-          </a:p>
-        </p:txBody>
-      </p:sp>
-      <p:sp>
-        <p:nvSpPr>
-          <p:cNvPr id="30" name="TextBox 29"/>
+              <a:t>Interpretación y evaluación</a:t>
+            </a:r>
+          </a:p>
+        </p:txBody>
+      </p:sp>
+      <p:sp>
+        <p:nvSpPr>
+          <p:cNvPr id="26" name="TextBox 25"/>
           <p:cNvSpPr txBox="1"/>
           <p:nvPr/>
         </p:nvSpPr>
         <p:spPr>
           <a:xfrm>
-            <a:off x="7213600" y="4572000"/>
-            <a:ext cx="4292600" cy="368300"/>
+            <a:off x="9639300" y="2946400"/>
+            <a:ext cx="1803400" cy="863600"/>
           </a:xfrm>
           <a:prstGeom prst="rect">
             <a:avLst/>
@@ -9133,7 +8968,7 @@
               <a:spcAft>
                 <a:spcPts val="0"/>
               </a:spcAft>
-              <a:defRPr sz="1300" b="0">
+              <a:defRPr sz="1140" b="0">
                 <a:solidFill>
                   <a:srgbClr val="12243B"/>
                 </a:solidFill>
@@ -9141,7 +8976,187 @@
               </a:defRPr>
             </a:pPr>
             <a:r>
-              <a:t>EEG + GSR</a:t>
+              <a:t>Comparar por participante, cuantificar incertidumbre y ablaciones; documentar hallazgos.</a:t>
+            </a:r>
+          </a:p>
+        </p:txBody>
+      </p:sp>
+      <p:sp>
+        <p:nvSpPr>
+          <p:cNvPr id="27" name="TextBox 26"/>
+          <p:cNvSpPr txBox="1"/>
+          <p:nvPr/>
+        </p:nvSpPr>
+        <p:spPr>
+          <a:xfrm>
+            <a:off x="635000" y="4013200"/>
+            <a:ext cx="10922000" cy="279400"/>
+          </a:xfrm>
+          <a:prstGeom prst="rect">
+            <a:avLst/>
+          </a:prstGeom>
+          <a:noFill/>
+        </p:spPr>
+        <p:txBody>
+          <a:bodyPr wrap="square" lIns="0" rIns="0" tIns="0" bIns="0">
+            <a:noAutofit/>
+          </a:bodyPr>
+          <a:lstStyle/>
+          <a:p>
+            <a:pPr>
+              <a:lnSpc>
+                <a:spcPct val="112000"/>
+              </a:lnSpc>
+              <a:spcBef>
+                <a:spcPts val="0"/>
+              </a:spcBef>
+              <a:spcAft>
+                <a:spcPts val="0"/>
+              </a:spcAft>
+              <a:defRPr sz="1150" b="0">
+                <a:solidFill>
+                  <a:srgbClr val="46556B"/>
+                </a:solidFill>
+                <a:latin typeface="Arial"/>
+              </a:defRPr>
+            </a:pPr>
+            <a:r>
+              <a:t>Modelo Profesor → pseudoetiqueta → Modelo Estudiante</a:t>
+            </a:r>
+          </a:p>
+        </p:txBody>
+      </p:sp>
+      <p:sp>
+        <p:nvSpPr>
+          <p:cNvPr id="28" name="TextBox 27"/>
+          <p:cNvSpPr txBox="1"/>
+          <p:nvPr/>
+        </p:nvSpPr>
+        <p:spPr>
+          <a:xfrm>
+            <a:off x="685800" y="4381500"/>
+            <a:ext cx="2159000" cy="368300"/>
+          </a:xfrm>
+          <a:prstGeom prst="rect">
+            <a:avLst/>
+          </a:prstGeom>
+          <a:noFill/>
+        </p:spPr>
+        <p:txBody>
+          <a:bodyPr wrap="square" lIns="0" rIns="0" tIns="0" bIns="0">
+            <a:noAutofit/>
+          </a:bodyPr>
+          <a:lstStyle/>
+          <a:p>
+            <a:pPr>
+              <a:lnSpc>
+                <a:spcPct val="112000"/>
+              </a:lnSpc>
+              <a:spcBef>
+                <a:spcPts val="0"/>
+              </a:spcBef>
+              <a:spcAft>
+                <a:spcPts val="0"/>
+              </a:spcAft>
+              <a:defRPr sz="1100" b="1">
+                <a:solidFill>
+                  <a:srgbClr val="46556B"/>
+                </a:solidFill>
+                <a:latin typeface="Arial"/>
+              </a:defRPr>
+            </a:pPr>
+            <a:r>
+              <a:t>Variable objetivo</a:t>
+            </a:r>
+          </a:p>
+        </p:txBody>
+      </p:sp>
+      <p:sp>
+        <p:nvSpPr>
+          <p:cNvPr id="29" name="TextBox 28"/>
+          <p:cNvSpPr txBox="1"/>
+          <p:nvPr/>
+        </p:nvSpPr>
+        <p:spPr>
+          <a:xfrm>
+            <a:off x="3175000" y="4381500"/>
+            <a:ext cx="3721100" cy="368300"/>
+          </a:xfrm>
+          <a:prstGeom prst="rect">
+            <a:avLst/>
+          </a:prstGeom>
+          <a:noFill/>
+        </p:spPr>
+        <p:txBody>
+          <a:bodyPr wrap="square" lIns="0" rIns="0" tIns="0" bIns="0">
+            <a:noAutofit/>
+          </a:bodyPr>
+          <a:lstStyle/>
+          <a:p>
+            <a:pPr>
+              <a:lnSpc>
+                <a:spcPct val="112000"/>
+              </a:lnSpc>
+              <a:spcBef>
+                <a:spcPts val="0"/>
+              </a:spcBef>
+              <a:spcAft>
+                <a:spcPts val="0"/>
+              </a:spcAft>
+              <a:defRPr sz="1100" b="1">
+                <a:solidFill>
+                  <a:srgbClr val="46556B"/>
+                </a:solidFill>
+                <a:latin typeface="Arial"/>
+              </a:defRPr>
+            </a:pPr>
+            <a:r>
+              <a:t>Profesor: construye la etiqueta</a:t>
+            </a:r>
+          </a:p>
+        </p:txBody>
+      </p:sp>
+      <p:sp>
+        <p:nvSpPr>
+          <p:cNvPr id="30" name="TextBox 29"/>
+          <p:cNvSpPr txBox="1"/>
+          <p:nvPr/>
+        </p:nvSpPr>
+        <p:spPr>
+          <a:xfrm>
+            <a:off x="7213600" y="4381500"/>
+            <a:ext cx="4292600" cy="368300"/>
+          </a:xfrm>
+          <a:prstGeom prst="rect">
+            <a:avLst/>
+          </a:prstGeom>
+          <a:noFill/>
+        </p:spPr>
+        <p:txBody>
+          <a:bodyPr wrap="square" lIns="0" rIns="0" tIns="0" bIns="0">
+            <a:noAutofit/>
+          </a:bodyPr>
+          <a:lstStyle/>
+          <a:p>
+            <a:pPr>
+              <a:lnSpc>
+                <a:spcPct val="112000"/>
+              </a:lnSpc>
+              <a:spcBef>
+                <a:spcPts val="0"/>
+              </a:spcBef>
+              <a:spcAft>
+                <a:spcPts val="0"/>
+              </a:spcAft>
+              <a:defRPr sz="1100" b="1">
+                <a:solidFill>
+                  <a:srgbClr val="46556B"/>
+                </a:solidFill>
+                <a:latin typeface="Arial"/>
+              </a:defRPr>
+            </a:pPr>
+            <a:r>
+              <a:t>Estudiante: predice</a:t>
             </a:r>
           </a:p>
         </p:txBody>
@@ -9154,7 +9169,7 @@
         </p:nvSpPr>
         <p:spPr>
           <a:xfrm>
-            <a:off x="635000" y="4953000"/>
+            <a:off x="635000" y="4762500"/>
             <a:ext cx="10922000" cy="7620"/>
           </a:xfrm>
           <a:prstGeom prst="rect">
@@ -9198,7 +9213,7 @@
         </p:nvSpPr>
         <p:spPr>
           <a:xfrm>
-            <a:off x="685800" y="5003800"/>
+            <a:off x="685800" y="4775200"/>
             <a:ext cx="2159000" cy="368300"/>
           </a:xfrm>
           <a:prstGeom prst="rect">
@@ -9230,7 +9245,7 @@
               </a:defRPr>
             </a:pPr>
             <a:r>
-              <a:t>Activación</a:t>
+              <a:t>Atención</a:t>
             </a:r>
           </a:p>
         </p:txBody>
@@ -9243,7 +9258,7 @@
         </p:nvSpPr>
         <p:spPr>
           <a:xfrm>
-            <a:off x="3175000" y="5003800"/>
+            <a:off x="3175000" y="4775200"/>
             <a:ext cx="3721100" cy="368300"/>
           </a:xfrm>
           <a:prstGeom prst="rect">
@@ -9275,7 +9290,7 @@
               </a:defRPr>
             </a:pPr>
             <a:r>
-              <a:t>GSR</a:t>
+              <a:t>Eye tracking + pupilometría</a:t>
             </a:r>
           </a:p>
         </p:txBody>
@@ -9288,7 +9303,7 @@
         </p:nvSpPr>
         <p:spPr>
           <a:xfrm>
-            <a:off x="7213600" y="5003800"/>
+            <a:off x="7213600" y="4775200"/>
             <a:ext cx="4292600" cy="368300"/>
           </a:xfrm>
           <a:prstGeom prst="rect">
@@ -9320,7 +9335,7 @@
               </a:defRPr>
             </a:pPr>
             <a:r>
-              <a:t>EEG + eye tracking + pupilometría</a:t>
+              <a:t>EEG + GSR</a:t>
             </a:r>
           </a:p>
         </p:txBody>
@@ -9333,7 +9348,7 @@
         </p:nvSpPr>
         <p:spPr>
           <a:xfrm>
-            <a:off x="635000" y="5384800"/>
+            <a:off x="635000" y="5156200"/>
             <a:ext cx="10922000" cy="7620"/>
           </a:xfrm>
           <a:prstGeom prst="rect">
@@ -9371,20 +9386,155 @@
       </p:sp>
       <p:sp>
         <p:nvSpPr>
-          <p:cNvPr id="36" name="Rectangle 35"/>
+          <p:cNvPr id="36" name="TextBox 35"/>
+          <p:cNvSpPr txBox="1"/>
+          <p:nvPr/>
+        </p:nvSpPr>
+        <p:spPr>
+          <a:xfrm>
+            <a:off x="685800" y="5168900"/>
+            <a:ext cx="2159000" cy="368300"/>
+          </a:xfrm>
+          <a:prstGeom prst="rect">
+            <a:avLst/>
+          </a:prstGeom>
+          <a:noFill/>
+        </p:spPr>
+        <p:txBody>
+          <a:bodyPr wrap="square" lIns="0" rIns="0" tIns="0" bIns="0">
+            <a:noAutofit/>
+          </a:bodyPr>
+          <a:lstStyle/>
+          <a:p>
+            <a:pPr>
+              <a:lnSpc>
+                <a:spcPct val="112000"/>
+              </a:lnSpc>
+              <a:spcBef>
+                <a:spcPts val="0"/>
+              </a:spcBef>
+              <a:spcAft>
+                <a:spcPts val="0"/>
+              </a:spcAft>
+              <a:defRPr sz="1300" b="1">
+                <a:solidFill>
+                  <a:srgbClr val="12243B"/>
+                </a:solidFill>
+                <a:latin typeface="Arial"/>
+              </a:defRPr>
+            </a:pPr>
+            <a:r>
+              <a:t>Activación</a:t>
+            </a:r>
+          </a:p>
+        </p:txBody>
+      </p:sp>
+      <p:sp>
+        <p:nvSpPr>
+          <p:cNvPr id="37" name="TextBox 36"/>
+          <p:cNvSpPr txBox="1"/>
+          <p:nvPr/>
+        </p:nvSpPr>
+        <p:spPr>
+          <a:xfrm>
+            <a:off x="3175000" y="5168900"/>
+            <a:ext cx="3721100" cy="368300"/>
+          </a:xfrm>
+          <a:prstGeom prst="rect">
+            <a:avLst/>
+          </a:prstGeom>
+          <a:noFill/>
+        </p:spPr>
+        <p:txBody>
+          <a:bodyPr wrap="square" lIns="0" rIns="0" tIns="0" bIns="0">
+            <a:noAutofit/>
+          </a:bodyPr>
+          <a:lstStyle/>
+          <a:p>
+            <a:pPr>
+              <a:lnSpc>
+                <a:spcPct val="112000"/>
+              </a:lnSpc>
+              <a:spcBef>
+                <a:spcPts val="0"/>
+              </a:spcBef>
+              <a:spcAft>
+                <a:spcPts val="0"/>
+              </a:spcAft>
+              <a:defRPr sz="1300" b="0">
+                <a:solidFill>
+                  <a:srgbClr val="12243B"/>
+                </a:solidFill>
+                <a:latin typeface="Arial"/>
+              </a:defRPr>
+            </a:pPr>
+            <a:r>
+              <a:t>GSR</a:t>
+            </a:r>
+          </a:p>
+        </p:txBody>
+      </p:sp>
+      <p:sp>
+        <p:nvSpPr>
+          <p:cNvPr id="38" name="TextBox 37"/>
+          <p:cNvSpPr txBox="1"/>
+          <p:nvPr/>
+        </p:nvSpPr>
+        <p:spPr>
+          <a:xfrm>
+            <a:off x="7213600" y="5168900"/>
+            <a:ext cx="4292600" cy="368300"/>
+          </a:xfrm>
+          <a:prstGeom prst="rect">
+            <a:avLst/>
+          </a:prstGeom>
+          <a:noFill/>
+        </p:spPr>
+        <p:txBody>
+          <a:bodyPr wrap="square" lIns="0" rIns="0" tIns="0" bIns="0">
+            <a:noAutofit/>
+          </a:bodyPr>
+          <a:lstStyle/>
+          <a:p>
+            <a:pPr>
+              <a:lnSpc>
+                <a:spcPct val="112000"/>
+              </a:lnSpc>
+              <a:spcBef>
+                <a:spcPts val="0"/>
+              </a:spcBef>
+              <a:spcAft>
+                <a:spcPts val="0"/>
+              </a:spcAft>
+              <a:defRPr sz="1300" b="0">
+                <a:solidFill>
+                  <a:srgbClr val="12243B"/>
+                </a:solidFill>
+                <a:latin typeface="Arial"/>
+              </a:defRPr>
+            </a:pPr>
+            <a:r>
+              <a:t>EEG + eye tracking + pupilometría</a:t>
+            </a:r>
+          </a:p>
+        </p:txBody>
+      </p:sp>
+      <p:sp>
+        <p:nvSpPr>
+          <p:cNvPr id="39" name="Rectangle 38"/>
           <p:cNvSpPr/>
           <p:nvPr/>
         </p:nvSpPr>
         <p:spPr>
           <a:xfrm>
-            <a:off x="635000" y="5511800"/>
-            <a:ext cx="10922000" cy="533400"/>
+            <a:off x="635000" y="5549900"/>
+            <a:ext cx="10922000" cy="7620"/>
           </a:xfrm>
           <a:prstGeom prst="rect">
             <a:avLst/>
           </a:prstGeom>
           <a:solidFill>
-            <a:srgbClr val="EFF4F9"/>
+            <a:srgbClr val="CCD7E2"/>
           </a:solidFill>
           <a:ln>
             <a:noFill/>
@@ -9415,14 +9565,58 @@
       </p:sp>
       <p:sp>
         <p:nvSpPr>
-          <p:cNvPr id="37" name="TextBox 36"/>
+          <p:cNvPr id="40" name="Rectangle 39"/>
+          <p:cNvSpPr/>
+          <p:nvPr/>
+        </p:nvSpPr>
+        <p:spPr>
+          <a:xfrm>
+            <a:off x="635000" y="5689600"/>
+            <a:ext cx="10922000" cy="457200"/>
+          </a:xfrm>
+          <a:prstGeom prst="rect">
+            <a:avLst/>
+          </a:prstGeom>
+          <a:solidFill>
+            <a:srgbClr val="EFF4F9"/>
+          </a:solidFill>
+          <a:ln>
+            <a:noFill/>
+          </a:ln>
+          <a:effectLst/>
+        </p:spPr>
+        <p:style>
+          <a:lnRef idx="1">
+            <a:schemeClr val="accent1"/>
+          </a:lnRef>
+          <a:fillRef idx="3">
+            <a:schemeClr val="accent1"/>
+          </a:fillRef>
+          <a:effectRef idx="2">
+            <a:schemeClr val="accent1"/>
+          </a:effectRef>
+          <a:fontRef idx="minor">
+            <a:schemeClr val="lt1"/>
+          </a:fontRef>
+        </p:style>
+        <p:txBody>
+          <a:bodyPr rtlCol="0" anchor="ctr"/>
+          <a:lstStyle/>
+          <a:p>
+            <a:pPr algn="ctr"/>
+          </a:p>
+        </p:txBody>
+      </p:sp>
+      <p:sp>
+        <p:nvSpPr>
+          <p:cNvPr id="41" name="TextBox 40"/>
           <p:cNvSpPr txBox="1"/>
           <p:nvPr/>
         </p:nvSpPr>
         <p:spPr>
           <a:xfrm>
-            <a:off x="774700" y="5600700"/>
-            <a:ext cx="10642600" cy="419100"/>
+            <a:off x="774700" y="5740400"/>
+            <a:ext cx="10642600" cy="368300"/>
           </a:xfrm>
           <a:prstGeom prst="rect">
             <a:avLst/>
@@ -9445,7 +9639,7 @@
               <a:spcAft>
                 <a:spcPts val="0"/>
               </a:spcAft>
-              <a:defRPr sz="1150" b="0">
+              <a:defRPr sz="1070" b="0">
                 <a:solidFill>
                   <a:srgbClr val="12243B"/>
                 </a:solidFill>
@@ -9453,7 +9647,7 @@
               </a:defRPr>
             </a:pPr>
             <a:r>
-              <a:t>Evaluación offline: BA macro por participante, macro-F1 y recall por clase; regresión para los scores continuos. Las pseudoetiquetas no constituyen una medición directa del estado interno.</a:t>
+              <a:t>Proceso iterativo: los resultados retroalimentan las etapas anteriores dentro del desarrollo. Evaluación offline con BA por participante, macro-F1 y recall; sin reutilizar la evaluación final para seleccionar modelos.</a:t>
             </a:r>
           </a:p>
         </p:txBody>

</xml_diff>

<commit_message>
Simplify thesis presentation wording and preserve scientific scope
</commit_message>
<xml_diff>
--- a/presentaciones/Presentacion-Tema-Tesis-Autocontenida-20-09-2026.pptx
+++ b/presentaciones/Presentacion-Tema-Tesis-Autocontenida-20-09-2026.pptx
@@ -553,7 +553,7 @@
           </a:p>
           <a:p>
             <a:r>
-              <a:t>Estudiar el aporte de la información temporal y de la fusión de señales neurofisiológicas para predecir atención y activación en otras personas.</a:t>
+              <a:t>Estudiar si combinar señales y considerar su evolución en el tiempo ayuda a predecir atención y activación en participantes nuevos.</a:t>
             </a:r>
           </a:p>
           <a:p>
@@ -563,7 +563,7 @@
           </a:p>
           <a:p>
             <a:r>
-              <a:t>Alcance operacional de activación emocional: arousal, sin inferir valencia ni emociones discretas.</a:t>
+              <a:t>La activación emocional se estudia como arousal; no se distinguen emociones como alegría o tristeza.</a:t>
             </a:r>
           </a:p>
         </p:txBody>
@@ -649,7 +649,7 @@
           </a:p>
           <a:p>
             <a:r>
-              <a:t>La navegación produce respuestas que cambian en el tiempo</a:t>
+              <a:t>Atención y activación cambian durante la navegación</a:t>
             </a:r>
           </a:p>
           <a:p>
@@ -669,27 +669,27 @@
           </a:p>
           <a:p>
             <a:r>
-              <a:t>Resumir una sesión en promedios elimina el orden temporal y puede ocultar cambios de atención o activación.</a:t>
-            </a:r>
-          </a:p>
-          <a:p>
-            <a:r>
-              <a:t>Desafío de medición</a:t>
-            </a:r>
-          </a:p>
-          <a:p>
-            <a:r>
-              <a:t>No se dispone de etiquetas directas y continuas. Mirar no demuestra atender; GSR aproxima activación, no emoción completa.</a:t>
-            </a:r>
-          </a:p>
-          <a:p>
-            <a:r>
-              <a:t>La tesis contrasta si conservar la historia y combinar señales mejora la predicción frente a modelos estáticos comparables.</a:t>
-            </a:r>
-          </a:p>
-          <a:p>
-            <a:r>
-              <a:t>Base conceptual: «Problema e hipótesis» y «Estructura Tesis», capítulo 1. La superioridad temporal es una hipótesis a evaluar.</a:t>
+              <a:t>Los promedios de una sesión pierden el orden de los datos y pueden ocultar cambios de atención o activación.</a:t>
+            </a:r>
+          </a:p>
+          <a:p>
+            <a:r>
+              <a:t>Medición</a:t>
+            </a:r>
+          </a:p>
+          <a:p>
+            <a:r>
+              <a:t>No hay etiquetas directas de atención y activación. Se estiman a partir de las señales, con las limitaciones de cada una.</a:t>
+            </a:r>
+          </a:p>
+          <a:p>
+            <a:r>
+              <a:t>Se comparan modelos que usan una ventana de datos con otros que consideran también las ventanas anteriores.</a:t>
+            </a:r>
+          </a:p>
+          <a:p>
+            <a:r>
+              <a:t>Fuentes: «Problema e hipótesis» y «Estructura Tesis», capítulo 1. Registrar la mirada no demuestra atención; GSR aproxima activación, sin distinguir emociones.</a:t>
             </a:r>
           </a:p>
         </p:txBody>
@@ -770,17 +770,17 @@
           <a:p/>
           <a:p>
             <a:r>
+              <a:t>Temporalidad y fusión multimodal</a:t>
+            </a:r>
+          </a:p>
+          <a:p>
+            <a:r>
               <a:t>Objetivo general</a:t>
             </a:r>
           </a:p>
           <a:p>
             <a:r>
-              <a:t>Evaluar el aporte predictivo de la temporalidad y la fusión</a:t>
-            </a:r>
-          </a:p>
-          <a:p>
-            <a:r>
-              <a:t>Evaluar el aporte de la información temporal y de la fusión multimodal a la predicción de pseudoetiquetas de atención y activación emocional durante la navegación web, mediante la comparación de modelos temporales y estáticos en participantes no utilizados para su ajuste.</a:t>
+              <a:t>Evaluar si la información temporal y la fusión multimodal mejoran la predicción de pseudoetiquetas de atención y activación emocional durante la navegación web, comparando modelos temporales y estáticos en participantes no utilizados para su ajuste.</a:t>
             </a:r>
           </a:p>
           <a:p>
@@ -810,7 +810,7 @@
           </a:p>
           <a:p>
             <a:r>
-              <a:t>Objetivo revisado el 22-09-2026. La comparación mantiene las mismas pseudoetiquetas y particiones; estima capacidad predictiva, sin atribuir validez fisiológica directa.</a:t>
+              <a:t>Se usan las mismas etiquetas y particiones para comparar los modelos. Las pseudoetiquetas son estimaciones de atención y activación.</a:t>
             </a:r>
           </a:p>
         </p:txBody>
@@ -891,87 +891,87 @@
           <a:p/>
           <a:p>
             <a:r>
+              <a:t>Plan de investigación</a:t>
+            </a:r>
+          </a:p>
+          <a:p>
+            <a:r>
               <a:t>Objetivos específicos</a:t>
             </a:r>
           </a:p>
           <a:p>
             <a:r>
-              <a:t>Caracterizar, comparar y contrastar con evidencia</a:t>
-            </a:r>
-          </a:p>
-          <a:p>
-            <a:r>
-              <a:t>Sistematizar la evidencia científica</a:t>
-            </a:r>
-          </a:p>
-          <a:p>
-            <a:r>
-              <a:t>sobre temporalidad y fusión multimodal para fundamentar el diseño experimental.</a:t>
-            </a:r>
-          </a:p>
-          <a:p>
-            <a:r>
-              <a:t>Caracterizar e integrar las señales</a:t>
-            </a:r>
-          </a:p>
-          <a:p>
-            <a:r>
-              <a:t>EEG, GSR, mirada y pupila mediante criterios reproducibles de calidad y sincronización.</a:t>
-            </a:r>
-          </a:p>
-          <a:p>
-            <a:r>
-              <a:t>Operacionalizar las variables objetivo</a:t>
-            </a:r>
-          </a:p>
-          <a:p>
-            <a:r>
-              <a:t>con pseudoetiquetas continuas y categóricas, evaluando su estabilidad y separando señales de etiquetado y predicción.</a:t>
-            </a:r>
-          </a:p>
-          <a:p>
-            <a:r>
-              <a:t>Comparar el desempeño predictivo</a:t>
-            </a:r>
-          </a:p>
-          <a:p>
-            <a:r>
-              <a:t>de modelos temporales y estáticos mediante evaluación por participante y selección interna de hiperparámetros.</a:t>
-            </a:r>
-          </a:p>
-          <a:p>
-            <a:r>
-              <a:t>Cuantificar el aporte de la fusión</a:t>
-            </a:r>
-          </a:p>
-          <a:p>
-            <a:r>
-              <a:t>temprana, intermedia y tardía, de las modalidades y del historial mediante comparaciones controladas y ablación.</a:t>
-            </a:r>
-          </a:p>
-          <a:p>
-            <a:r>
-              <a:t>Caracterizar las trayectorias intra-sesión</a:t>
-            </a:r>
-          </a:p>
-          <a:p>
-            <a:r>
-              <a:t>de los scores para identificar patrones compatibles con fatiga o habituación, con alcance descriptivo.</a:t>
-            </a:r>
-          </a:p>
-          <a:p>
-            <a:r>
-              <a:t>Contrastar la hipótesis de investigación</a:t>
-            </a:r>
-          </a:p>
-          <a:p>
-            <a:r>
-              <a:t>estimando la incertidumbre y la variabilidad entre participantes de las diferencias de desempeño.</a:t>
-            </a:r>
-          </a:p>
-          <a:p>
-            <a:r>
-              <a:t>Formulación revisada en «Estructura Tesis», 22-09-2026. La estabilidad de las pseudoetiquetas no equivale a validación externa de los constructos.</a:t>
+              <a:t>Revisar la literatura</a:t>
+            </a:r>
+          </a:p>
+          <a:p>
+            <a:r>
+              <a:t>sobre atención y activación emocional, con énfasis en modelos temporales y fusión de señales.</a:t>
+            </a:r>
+          </a:p>
+          <a:p>
+            <a:r>
+              <a:t>Caracterizar las señales disponibles</a:t>
+            </a:r>
+          </a:p>
+          <a:p>
+            <a:r>
+              <a:t>y sincronizar EEG, GSR, eye tracking y pupilometría con criterios de calidad definidos.</a:t>
+            </a:r>
+          </a:p>
+          <a:p>
+            <a:r>
+              <a:t>Definir las pseudoetiquetas</a:t>
+            </a:r>
+          </a:p>
+          <a:p>
+            <a:r>
+              <a:t>continuas y categóricas de atención y activación, comprobar su estabilidad y separar las señales de etiquetado y predicción.</a:t>
+            </a:r>
+          </a:p>
+          <a:p>
+            <a:r>
+              <a:t>Comparar modelos temporales y estáticos</a:t>
+            </a:r>
+          </a:p>
+          <a:p>
+            <a:r>
+              <a:t>en participantes no usados para su ajuste, seleccionando hiperparámetros dentro del entrenamiento.</a:t>
+            </a:r>
+          </a:p>
+          <a:p>
+            <a:r>
+              <a:t>Medir el aporte de señales e historial</a:t>
+            </a:r>
+          </a:p>
+          <a:p>
+            <a:r>
+              <a:t>mediante estudios de ablación y comparaciones entre fusión temprana, intermedia y tardía.</a:t>
+            </a:r>
+          </a:p>
+          <a:p>
+            <a:r>
+              <a:t>Describir los cambios durante la sesión</a:t>
+            </a:r>
+          </a:p>
+          <a:p>
+            <a:r>
+              <a:t>en los scores de atención y activación, buscando patrones compatibles con fatiga o habituación.</a:t>
+            </a:r>
+          </a:p>
+          <a:p>
+            <a:r>
+              <a:t>Contrastar la hipótesis</a:t>
+            </a:r>
+          </a:p>
+          <a:p>
+            <a:r>
+              <a:t>a partir de las diferencias de desempeño, sus intervalos de incertidumbre y la variación entre participantes.</a:t>
+            </a:r>
+          </a:p>
+          <a:p>
+            <a:r>
+              <a:t>El análisis de fatiga y habituación es descriptivo. Las pseudoetiquetas se mantienen fijas al comparar modelos.</a:t>
             </a:r>
           </a:p>
         </p:txBody>
@@ -1052,12 +1052,12 @@
           <a:p/>
           <a:p>
             <a:r>
-              <a:t>Metodología · Knowledge Discovery in Databases</a:t>
-            </a:r>
-          </a:p>
-          <a:p>
-            <a:r>
-              <a:t>KDD como marco del análisis multimodal</a:t>
+              <a:t>Knowledge Discovery in Databases</a:t>
+            </a:r>
+          </a:p>
+          <a:p>
+            <a:r>
+              <a:t>Metodología KDD</a:t>
             </a:r>
           </a:p>
           <a:p>
@@ -1067,7 +1067,7 @@
           </a:p>
           <a:p>
             <a:r>
-              <a:t>Delimitar participantes, sesiones y señales de la Toma de Muestra 2.</a:t>
+              <a:t>Seleccionar los registros de la Toma de Muestra 2.</a:t>
             </a:r>
           </a:p>
           <a:p>
@@ -1077,7 +1077,7 @@
           </a:p>
           <a:p>
             <a:r>
-              <a:t>Auditar calidad, tratar faltantes y sincronizar registros.</a:t>
+              <a:t>Revisar la calidad, tratar datos faltantes y sincronizar las señales.</a:t>
             </a:r>
           </a:p>
           <a:p>
@@ -1087,7 +1087,7 @@
           </a:p>
           <a:p>
             <a:r>
-              <a:t>Extraer características y pseudoetiquetas en ventanas; construir secuencias.</a:t>
+              <a:t>Calcular características y pseudoetiquetas por ventana; formar secuencias.</a:t>
             </a:r>
           </a:p>
           <a:p>
@@ -1097,7 +1097,7 @@
           </a:p>
           <a:p>
             <a:r>
-              <a:t>Ajustar modelos estáticos y temporales, fusiones e hiperparámetros dentro de entrenamiento.</a:t>
+              <a:t>Entrenar modelos, probar fusiones y ajustar hiperparámetros dentro del entrenamiento.</a:t>
             </a:r>
           </a:p>
           <a:p>
@@ -1107,7 +1107,7 @@
           </a:p>
           <a:p>
             <a:r>
-              <a:t>Comparar por participante, cuantificar incertidumbre y ablaciones; documentar hallazgos.</a:t>
+              <a:t>Comparar resultados, estimar incertidumbre y analizar el aporte de señales e historial.</a:t>
             </a:r>
           </a:p>
           <a:p>
@@ -1162,17 +1162,17 @@
           </a:p>
           <a:p>
             <a:r>
-              <a:t>Proceso iterativo:</a:t>
-            </a:r>
-          </a:p>
-          <a:p>
-            <a:r>
-              <a:t>los resultados retroalimentan las etapas anteriores dentro del desarrollo. Evaluación offline con BA por participante, macro-F1 y recall; sin reutilizar la evaluación final para seleccionar modelos.</a:t>
-            </a:r>
-          </a:p>
-          <a:p>
-            <a:r>
-              <a:t>Adaptación en cinco bloques de KDD: Fayyad, Piatetsky-Shapiro y Smyth (1996), AI Magazine 17(3), 37–54. DOI: 10.1609/aimag.v17i3.1230. La normalización original por sesión limita la interpretación en tiempo real.</a:t>
+              <a:t>Las etapas se revisan durante el desarrollo. Se evalúa por participante con exactitud balanceada (BA), macro-F1 y recall. La evaluación final se reserva hasta cerrar el ajuste.</a:t>
+            </a:r>
+          </a:p>
+          <a:p>
+            <a:r>
+              <a:t>KDD adaptado de Fayyad, Piatetsky-Shapiro y Smyth (1996), AI Magazine 17(3), 37–54. DOI: 10.1609/aimag.v17i3.1230.</a:t>
+            </a:r>
+          </a:p>
+          <a:p>
+            <a:r>
+              <a:t>El análisis es offline: la normalización por sesión requiere disponer del registro completo.</a:t>
             </a:r>
           </a:p>
         </p:txBody>
@@ -1253,12 +1253,12 @@
           <a:p/>
           <a:p>
             <a:r>
-              <a:t>Datos disponibles · Toma de Muestra 2</a:t>
-            </a:r>
-          </a:p>
-          <a:p>
-            <a:r>
-              <a:t>Cuatro señales registradas durante navegación web en laboratorio</a:t>
+              <a:t>Datos disponibles</a:t>
+            </a:r>
+          </a:p>
+          <a:p>
+            <a:r>
+              <a:t>Datos de la Toma de Muestra 2</a:t>
             </a:r>
           </a:p>
           <a:p>
@@ -4531,7 +4531,7 @@
               </a:defRPr>
             </a:pPr>
             <a:r>
-              <a:t>Proyecto Fondecyt 1231122 · Toma de Muestra 2 · Revisión del 22 de septiembre de 2026. Alcance operacional de activación emocional: arousal, sin inferir valencia ni emociones discretas.</a:t>
+              <a:t>Proyecto Fondecyt 1231122 · Toma de Muestra 2 · Revisión del 22 de septiembre de 2026. La activación emocional se estudia como arousal; no se distinguen emociones como alegría o tristeza.</a:t>
             </a:r>
           </a:p>
         </p:txBody>
@@ -4979,7 +4979,7 @@
               </a:defRPr>
             </a:pPr>
             <a:r>
-              <a:t>Estudiar el aporte de la información temporal y de la fusión de señales neurofisiológicas para predecir atención y activación en otras personas.</a:t>
+              <a:t>Estudiar si combinar señales y considerar su evolución en el tiempo ayuda a predecir atención y activación en participantes nuevos.</a:t>
             </a:r>
           </a:p>
         </p:txBody>
@@ -5139,7 +5139,7 @@
               </a:defRPr>
             </a:pPr>
             <a:r>
-              <a:t>La navegación produce respuestas que cambian en el tiempo</a:t>
+              <a:t>Atención y activación cambian durante la navegación</a:t>
             </a:r>
           </a:p>
         </p:txBody>
@@ -5184,7 +5184,7 @@
               </a:defRPr>
             </a:pPr>
             <a:r>
-              <a:t>Base conceptual: «Problema e hipótesis» y «Estructura Tesis», capítulo 1. La superioridad temporal es una hipótesis a evaluar.</a:t>
+              <a:t>Fuentes: «Problema e hipótesis» y «Estructura Tesis», capítulo 1. Registrar la mirada no demuestra atención; GSR aproxima activación, sin distinguir emociones.</a:t>
             </a:r>
           </a:p>
         </p:txBody>
@@ -5375,8 +5375,8 @@
         </p:nvSpPr>
         <p:spPr>
           <a:xfrm>
-            <a:off x="863600" y="2730500"/>
-            <a:ext cx="2997200" cy="1816100"/>
+            <a:off x="838200" y="2730500"/>
+            <a:ext cx="3048000" cy="1816100"/>
           </a:xfrm>
           <a:prstGeom prst="rect">
             <a:avLst/>
@@ -5553,8 +5553,8 @@
         </p:nvSpPr>
         <p:spPr>
           <a:xfrm>
-            <a:off x="4597400" y="2730500"/>
-            <a:ext cx="2997200" cy="1816100"/>
+            <a:off x="4572000" y="2730500"/>
+            <a:ext cx="3048000" cy="1816100"/>
           </a:xfrm>
           <a:prstGeom prst="rect">
             <a:avLst/>
@@ -5585,7 +5585,7 @@
               </a:defRPr>
             </a:pPr>
             <a:r>
-              <a:t>Resumir una sesión en promedios elimina el orden temporal y puede ocultar cambios de atención o activación.</a:t>
+              <a:t>Los promedios de una sesión pierden el orden de los datos y pueden ocultar cambios de atención o activación.</a:t>
             </a:r>
           </a:p>
         </p:txBody>
@@ -5718,7 +5718,7 @@
               </a:defRPr>
             </a:pPr>
             <a:r>
-              <a:t>Desafío de medición</a:t>
+              <a:t>Medición</a:t>
             </a:r>
           </a:p>
         </p:txBody>
@@ -5731,8 +5731,8 @@
         </p:nvSpPr>
         <p:spPr>
           <a:xfrm>
-            <a:off x="8331200" y="2730500"/>
-            <a:ext cx="2997200" cy="1816100"/>
+            <a:off x="8305800" y="2730500"/>
+            <a:ext cx="3048000" cy="1816100"/>
           </a:xfrm>
           <a:prstGeom prst="rect">
             <a:avLst/>
@@ -5763,7 +5763,7 @@
               </a:defRPr>
             </a:pPr>
             <a:r>
-              <a:t>No se dispone de etiquetas directas y continuas. Mirar no demuestra atender; GSR aproxima activación, no emoción completa.</a:t>
+              <a:t>No hay etiquetas directas de atención y activación. Se estiman a partir de las señales, con las limitaciones de cada una.</a:t>
             </a:r>
           </a:p>
         </p:txBody>
@@ -5865,7 +5865,7 @@
         <p:spPr>
           <a:xfrm>
             <a:off x="863600" y="5168900"/>
-            <a:ext cx="10426700" cy="647700"/>
+            <a:ext cx="10528300" cy="647700"/>
           </a:xfrm>
           <a:prstGeom prst="rect">
             <a:avLst/>
@@ -5896,7 +5896,7 @@
               </a:defRPr>
             </a:pPr>
             <a:r>
-              <a:t>La tesis contrasta si conservar la historia y combinar señales mejora la predicción frente a modelos estáticos comparables.</a:t>
+              <a:t>Se comparan modelos que usan una ventana de datos con otros que consideran también las ventanas anteriores.</a:t>
             </a:r>
           </a:p>
         </p:txBody>
@@ -6011,7 +6011,7 @@
               </a:defRPr>
             </a:pPr>
             <a:r>
-              <a:t>OBJETIVO GENERAL</a:t>
+              <a:t>TEMPORALIDAD Y FUSIÓN MULTIMODAL</a:t>
             </a:r>
           </a:p>
         </p:txBody>
@@ -6056,7 +6056,7 @@
               </a:defRPr>
             </a:pPr>
             <a:r>
-              <a:t>Evaluar el aporte predictivo de la temporalidad y la fusión</a:t>
+              <a:t>Objetivo general</a:t>
             </a:r>
           </a:p>
         </p:txBody>
@@ -6101,7 +6101,7 @@
               </a:defRPr>
             </a:pPr>
             <a:r>
-              <a:t>Objetivo revisado el 22-09-2026. La comparación mantiene las mismas pseudoetiquetas y particiones; estima capacidad predictiva, sin atribuir validez fisiológica directa.</a:t>
+              <a:t>Se usan las mismas etiquetas y particiones para comparar los modelos. Las pseudoetiquetas son estimaciones de atención y activación.</a:t>
             </a:r>
           </a:p>
         </p:txBody>
@@ -6235,7 +6235,7 @@
               </a:defRPr>
             </a:pPr>
             <a:r>
-              <a:t>Evaluar el aporte de la información temporal y de la fusión multimodal a la predicción de pseudoetiquetas de atención y activación emocional durante la navegación web, mediante la comparación de modelos temporales y estáticos en participantes no utilizados para su ajuste.</a:t>
+              <a:t>Evaluar si la información temporal y la fusión multimodal mejoran la predicción de pseudoetiquetas de atención y activación emocional durante la navegación web, comparando modelos temporales y estáticos en participantes no utilizados para su ajuste.</a:t>
             </a:r>
           </a:p>
         </p:txBody>
@@ -6381,8 +6381,8 @@
         </p:nvSpPr>
         <p:spPr>
           <a:xfrm>
-            <a:off x="863600" y="5321300"/>
-            <a:ext cx="4584700" cy="228600"/>
+            <a:off x="838200" y="5321300"/>
+            <a:ext cx="4635500" cy="228600"/>
           </a:xfrm>
           <a:prstGeom prst="rect">
             <a:avLst/>
@@ -6559,8 +6559,8 @@
         </p:nvSpPr>
         <p:spPr>
           <a:xfrm>
-            <a:off x="6743700" y="5321300"/>
-            <a:ext cx="4584700" cy="228600"/>
+            <a:off x="6718300" y="5321300"/>
+            <a:ext cx="4635500" cy="228600"/>
           </a:xfrm>
           <a:prstGeom prst="rect">
             <a:avLst/>
@@ -6751,7 +6751,7 @@
               </a:defRPr>
             </a:pPr>
             <a:r>
-              <a:t>OBJETIVOS ESPECÍFICOS</a:t>
+              <a:t>PLAN DE INVESTIGACIÓN</a:t>
             </a:r>
           </a:p>
         </p:txBody>
@@ -6796,7 +6796,7 @@
               </a:defRPr>
             </a:pPr>
             <a:r>
-              <a:t>Caracterizar, comparar y contrastar con evidencia</a:t>
+              <a:t>Objetivos específicos</a:t>
             </a:r>
           </a:p>
         </p:txBody>
@@ -6841,7 +6841,7 @@
               </a:defRPr>
             </a:pPr>
             <a:r>
-              <a:t>Formulación revisada en «Estructura Tesis», 22-09-2026. La estabilidad de las pseudoetiquetas no equivale a validación externa de los constructos.</a:t>
+              <a:t>El análisis de fatiga y habituación es descriptivo. Las pseudoetiquetas se mantienen fijas al comparar modelos.</a:t>
             </a:r>
           </a:p>
         </p:txBody>
@@ -6976,7 +6976,7 @@
               </a:defRPr>
             </a:pPr>
             <a:r>
-              <a:t>Sistematizar la evidencia científica</a:t>
+              <a:t>Revisar la literatura</a:t>
             </a:r>
           </a:p>
         </p:txBody>
@@ -7021,7 +7021,7 @@
               </a:defRPr>
             </a:pPr>
             <a:r>
-              <a:t>sobre temporalidad y fusión multimodal para fundamentar el diseño experimental.</a:t>
+              <a:t>sobre atención y activación emocional, con énfasis en modelos temporales y fusión de señales.</a:t>
             </a:r>
           </a:p>
         </p:txBody>
@@ -7111,7 +7111,7 @@
               </a:defRPr>
             </a:pPr>
             <a:r>
-              <a:t>Caracterizar e integrar las señales</a:t>
+              <a:t>Caracterizar las señales disponibles</a:t>
             </a:r>
           </a:p>
         </p:txBody>
@@ -7156,7 +7156,7 @@
               </a:defRPr>
             </a:pPr>
             <a:r>
-              <a:t>EEG, GSR, mirada y pupila mediante criterios reproducibles de calidad y sincronización.</a:t>
+              <a:t>y sincronizar EEG, GSR, eye tracking y pupilometría con criterios de calidad definidos.</a:t>
             </a:r>
           </a:p>
         </p:txBody>
@@ -7246,7 +7246,7 @@
               </a:defRPr>
             </a:pPr>
             <a:r>
-              <a:t>Operacionalizar las variables objetivo</a:t>
+              <a:t>Definir las pseudoetiquetas</a:t>
             </a:r>
           </a:p>
         </p:txBody>
@@ -7291,7 +7291,7 @@
               </a:defRPr>
             </a:pPr>
             <a:r>
-              <a:t>con pseudoetiquetas continuas y categóricas, evaluando su estabilidad y separando señales de etiquetado y predicción.</a:t>
+              <a:t>continuas y categóricas de atención y activación, comprobar su estabilidad y separar las señales de etiquetado y predicción.</a:t>
             </a:r>
           </a:p>
         </p:txBody>
@@ -7381,7 +7381,7 @@
               </a:defRPr>
             </a:pPr>
             <a:r>
-              <a:t>Comparar el desempeño predictivo</a:t>
+              <a:t>Comparar modelos temporales y estáticos</a:t>
             </a:r>
           </a:p>
         </p:txBody>
@@ -7426,7 +7426,7 @@
               </a:defRPr>
             </a:pPr>
             <a:r>
-              <a:t>de modelos temporales y estáticos mediante evaluación por participante y selección interna de hiperparámetros.</a:t>
+              <a:t>en participantes no usados para su ajuste, seleccionando hiperparámetros dentro del entrenamiento.</a:t>
             </a:r>
           </a:p>
         </p:txBody>
@@ -7439,7 +7439,7 @@
         </p:nvSpPr>
         <p:spPr>
           <a:xfrm>
-            <a:off x="6350000" y="2997200"/>
+            <a:off x="6350000" y="3124200"/>
             <a:ext cx="317500" cy="317500"/>
           </a:xfrm>
           <a:prstGeom prst="rect">
@@ -7484,7 +7484,7 @@
         </p:nvSpPr>
         <p:spPr>
           <a:xfrm>
-            <a:off x="6743700" y="2997200"/>
+            <a:off x="6743700" y="3124200"/>
             <a:ext cx="4673600" cy="330200"/>
           </a:xfrm>
           <a:prstGeom prst="rect">
@@ -7516,7 +7516,7 @@
               </a:defRPr>
             </a:pPr>
             <a:r>
-              <a:t>Cuantificar el aporte de la fusión</a:t>
+              <a:t>Medir el aporte de señales e historial</a:t>
             </a:r>
           </a:p>
         </p:txBody>
@@ -7529,7 +7529,7 @@
         </p:nvSpPr>
         <p:spPr>
           <a:xfrm>
-            <a:off x="6743700" y="3352800"/>
+            <a:off x="6743700" y="3479800"/>
             <a:ext cx="4673600" cy="774700"/>
           </a:xfrm>
           <a:prstGeom prst="rect">
@@ -7561,7 +7561,7 @@
               </a:defRPr>
             </a:pPr>
             <a:r>
-              <a:t>temprana, intermedia y tardía, de las modalidades y del historial mediante comparaciones controladas y ablación.</a:t>
+              <a:t>mediante estudios de ablación y comparaciones entre fusión temprana, intermedia y tardía.</a:t>
             </a:r>
           </a:p>
         </p:txBody>
@@ -7651,7 +7651,7 @@
               </a:defRPr>
             </a:pPr>
             <a:r>
-              <a:t>Caracterizar las trayectorias intra-sesión</a:t>
+              <a:t>Describir los cambios durante la sesión</a:t>
             </a:r>
           </a:p>
         </p:txBody>
@@ -7696,7 +7696,7 @@
               </a:defRPr>
             </a:pPr>
             <a:r>
-              <a:t>de los scores para identificar patrones compatibles con fatiga o habituación, con alcance descriptivo.</a:t>
+              <a:t>en los scores de atención y activación, buscando patrones compatibles con fatiga o habituación.</a:t>
             </a:r>
           </a:p>
         </p:txBody>
@@ -7786,7 +7786,7 @@
               </a:defRPr>
             </a:pPr>
             <a:r>
-              <a:t>Contrastar la hipótesis de investigación</a:t>
+              <a:t>Contrastar la hipótesis</a:t>
             </a:r>
           </a:p>
         </p:txBody>
@@ -7831,7 +7831,7 @@
               </a:defRPr>
             </a:pPr>
             <a:r>
-              <a:t>estimando la incertidumbre y la variabilidad entre participantes de las diferencias de desempeño.</a:t>
+              <a:t>a partir de las diferencias de desempeño, sus intervalos de incertidumbre y la variación entre participantes.</a:t>
             </a:r>
           </a:p>
         </p:txBody>
@@ -7946,7 +7946,7 @@
               </a:defRPr>
             </a:pPr>
             <a:r>
-              <a:t>METODOLOGÍA · KNOWLEDGE DISCOVERY IN DATABASES</a:t>
+              <a:t>KNOWLEDGE DISCOVERY IN DATABASES</a:t>
             </a:r>
           </a:p>
         </p:txBody>
@@ -7991,7 +7991,7 @@
               </a:defRPr>
             </a:pPr>
             <a:r>
-              <a:t>KDD como marco del análisis multimodal</a:t>
+              <a:t>Metodología KDD</a:t>
             </a:r>
           </a:p>
         </p:txBody>
@@ -8036,7 +8036,7 @@
               </a:defRPr>
             </a:pPr>
             <a:r>
-              <a:t>Adaptación en cinco bloques de KDD: Fayyad, Piatetsky-Shapiro y Smyth (1996), AI Magazine 17(3), 37–54. DOI: 10.1609/aimag.v17i3.1230. La normalización original por sesión limita la interpretación en tiempo real.</a:t>
+              <a:t>KDD adaptado de Fayyad, Piatetsky-Shapiro y Smyth (1996), AI Magazine 17(3), 37–54. DOI: 10.1609/aimag.v17i3.1230. El análisis es offline: la normalización por sesión requiere disponer del registro completo.</a:t>
             </a:r>
           </a:p>
         </p:txBody>
@@ -8260,7 +8260,7 @@
               </a:defRPr>
             </a:pPr>
             <a:r>
-              <a:t>Delimitar participantes, sesiones y señales de la Toma de Muestra 2.</a:t>
+              <a:t>Seleccionar los registros de la Toma de Muestra 2.</a:t>
             </a:r>
           </a:p>
         </p:txBody>
@@ -8407,8 +8407,8 @@
         </p:nvSpPr>
         <p:spPr>
           <a:xfrm>
-            <a:off x="2971800" y="2946400"/>
-            <a:ext cx="1803400" cy="863600"/>
+            <a:off x="2946400" y="2946400"/>
+            <a:ext cx="1854200" cy="863600"/>
           </a:xfrm>
           <a:prstGeom prst="rect">
             <a:avLst/>
@@ -8439,7 +8439,7 @@
               </a:defRPr>
             </a:pPr>
             <a:r>
-              <a:t>Auditar calidad, tratar faltantes y sincronizar registros.</a:t>
+              <a:t>Revisar la calidad, tratar datos faltantes y sincronizar las señales.</a:t>
             </a:r>
           </a:p>
         </p:txBody>
@@ -8618,7 +8618,7 @@
               </a:defRPr>
             </a:pPr>
             <a:r>
-              <a:t>Extraer características y pseudoetiquetas en ventanas; construir secuencias.</a:t>
+              <a:t>Calcular características y pseudoetiquetas por ventana; formar secuencias.</a:t>
             </a:r>
           </a:p>
         </p:txBody>
@@ -8797,7 +8797,7 @@
               </a:defRPr>
             </a:pPr>
             <a:r>
-              <a:t>Ajustar modelos estáticos y temporales, fusiones e hiperparámetros dentro de entrenamiento.</a:t>
+              <a:t>Entrenar modelos, probar fusiones y ajustar hiperparámetros dentro del entrenamiento.</a:t>
             </a:r>
           </a:p>
         </p:txBody>
@@ -8976,7 +8976,7 @@
               </a:defRPr>
             </a:pPr>
             <a:r>
-              <a:t>Comparar por participante, cuantificar incertidumbre y ablaciones; documentar hallazgos.</a:t>
+              <a:t>Comparar resultados, estimar incertidumbre y analizar el aporte de señales e historial.</a:t>
             </a:r>
           </a:p>
         </p:txBody>
@@ -9647,7 +9647,7 @@
               </a:defRPr>
             </a:pPr>
             <a:r>
-              <a:t>Proceso iterativo: los resultados retroalimentan las etapas anteriores dentro del desarrollo. Evaluación offline con BA por participante, macro-F1 y recall; sin reutilizar la evaluación final para seleccionar modelos.</a:t>
+              <a:t>Las etapas se revisan durante el desarrollo. Se evalúa por participante con exactitud balanceada (BA), macro-F1 y recall. La evaluación final se reserva hasta cerrar el ajuste.</a:t>
             </a:r>
           </a:p>
         </p:txBody>
@@ -9762,7 +9762,7 @@
               </a:defRPr>
             </a:pPr>
             <a:r>
-              <a:t>DATOS DISPONIBLES · TOMA DE MUESTRA 2</a:t>
+              <a:t>DATOS DISPONIBLES</a:t>
             </a:r>
           </a:p>
         </p:txBody>
@@ -9807,7 +9807,7 @@
               </a:defRPr>
             </a:pPr>
             <a:r>
-              <a:t>Cuatro señales registradas durante navegación web en laboratorio</a:t>
+              <a:t>Datos de la Toma de Muestra 2</a:t>
             </a:r>
           </a:p>
         </p:txBody>

</xml_diff>